<commit_message>
Add Lecture 3 slides, expand deck, add instructor-private folder
</commit_message>
<xml_diff>
--- a/certifications/clf-c02-cloud-practitioner/lectures/03-aws-global-infrastructure-overview.pptx
+++ b/certifications/clf-c02-cloud-practitioner/lectures/03-aws-global-infrastructure-overview.pptx
@@ -20,6 +20,11 @@
     <p:sldId id="291" r:id="rId42"/>
     <p:sldId id="292" r:id="rId43"/>
     <p:sldId id="293" r:id="rId44"/>
+    <p:sldId id="294" r:id="rId45"/>
+    <p:sldId id="295" r:id="rId46"/>
+    <p:sldId id="296" r:id="rId47"/>
+    <p:sldId id="297" r:id="rId48"/>
+    <p:sldId id="298" r:id="rId49"/>
   </p:sldIdLst>
   <p:notesMasterIdLst>
     <p:notesMasterId r:id="rId25"/>
@@ -7697,6 +7702,4254 @@
 
 <file path=ppt/slides/slide33.xml><?xml version="1.0" encoding="utf-8"?>
 <p:sld xmlns:a="http://schemas.openxmlformats.org/drawingml/2006/main" xmlns:r="http://schemas.openxmlformats.org/officeDocument/2006/relationships" xmlns:p="http://schemas.openxmlformats.org/presentationml/2006/main">
+  <p:cSld name="Slide 5">
+    <p:bg>
+      <p:bgPr>
+        <a:solidFill>
+          <a:srgbClr val="F4F6F8"/>
+        </a:solidFill>
+      </p:bgPr>
+    </p:bg>
+    <p:spTree>
+      <p:nvGrpSpPr>
+        <p:cNvPr id="1" name=""/>
+        <p:cNvGrpSpPr/>
+        <p:nvPr/>
+      </p:nvGrpSpPr>
+      <p:grpSpPr>
+        <a:xfrm>
+          <a:off x="0" y="0"/>
+          <a:ext cx="0" cy="0"/>
+          <a:chOff x="0" y="0"/>
+          <a:chExt cx="0" cy="0"/>
+        </a:xfrm>
+      </p:grpSpPr>
+      <p:sp>
+        <p:nvSpPr>
+          <p:cNvPr id="2" name="Text 0"/>
+          <p:cNvSpPr/>
+          <p:nvPr/>
+        </p:nvSpPr>
+        <p:spPr>
+          <a:xfrm>
+            <a:off x="640080" y="457200"/>
+            <a:ext cx="10908792" cy="274320"/>
+          </a:xfrm>
+          <a:prstGeom prst="rect">
+            <a:avLst/>
+          </a:prstGeom>
+          <a:noFill/>
+          <a:ln/>
+        </p:spPr>
+        <p:txBody>
+          <a:bodyPr wrap="square" rtlCol="0" anchor="ctr"/>
+          <a:lstStyle/>
+          <a:p>
+            <a:pPr indent="0" marL="0">
+              <a:buNone/>
+            </a:pPr>
+            <a:r>
+              <a:rPr lang="en-US" sz="1200" b="1" spc="200" kern="0" dirty="0">
+                <a:solidFill>
+                  <a:srgbClr val="EC7211"/>
+                </a:solidFill>
+                <a:latin typeface="Calibri" pitchFamily="34" charset="0"/>
+                <a:ea typeface="Calibri" pitchFamily="34" charset="-122"/>
+                <a:cs typeface="Calibri" pitchFamily="34" charset="-120"/>
+              </a:rPr>
+              <a:t>EXTENDING EVEN FURTHER</a:t>
+            </a:r>
+            <a:endParaRPr lang="en-US" sz="1200" dirty="0"/>
+          </a:p>
+        </p:txBody>
+      </p:sp>
+      <p:sp>
+        <p:nvSpPr>
+          <p:cNvPr id="3" name="Text 1"/>
+          <p:cNvSpPr/>
+          <p:nvPr/>
+        </p:nvSpPr>
+        <p:spPr>
+          <a:xfrm>
+            <a:off x="640080" y="731520"/>
+            <a:ext cx="10908792" cy="640080"/>
+          </a:xfrm>
+          <a:prstGeom prst="rect">
+            <a:avLst/>
+          </a:prstGeom>
+          <a:noFill/>
+          <a:ln/>
+        </p:spPr>
+        <p:txBody>
+          <a:bodyPr wrap="square" rtlCol="0" anchor="ctr"/>
+          <a:lstStyle/>
+          <a:p>
+            <a:pPr indent="0" marL="0">
+              <a:buNone/>
+            </a:pPr>
+            <a:r>
+              <a:rPr lang="en-US" sz="3200" b="1" dirty="0">
+                <a:solidFill>
+                  <a:srgbClr val="232F3E"/>
+                </a:solidFill>
+                <a:latin typeface="Calibri" pitchFamily="34" charset="0"/>
+                <a:ea typeface="Calibri" pitchFamily="34" charset="-122"/>
+                <a:cs typeface="Calibri" pitchFamily="34" charset="-120"/>
+              </a:rPr>
+              <a:t>AWS Outposts — Bringing AWS On-Premises</a:t>
+            </a:r>
+            <a:endParaRPr lang="en-US" sz="3200" dirty="0"/>
+          </a:p>
+        </p:txBody>
+      </p:sp>
+      <p:sp>
+        <p:nvSpPr>
+          <p:cNvPr id="4" name="Text 2"/>
+          <p:cNvSpPr/>
+          <p:nvPr/>
+        </p:nvSpPr>
+        <p:spPr>
+          <a:xfrm>
+            <a:off x="640080" y="1417320"/>
+            <a:ext cx="10908792" cy="365760"/>
+          </a:xfrm>
+          <a:prstGeom prst="rect">
+            <a:avLst/>
+          </a:prstGeom>
+          <a:noFill/>
+          <a:ln/>
+        </p:spPr>
+        <p:txBody>
+          <a:bodyPr wrap="square" rtlCol="0" anchor="ctr"/>
+          <a:lstStyle/>
+          <a:p>
+            <a:pPr indent="0" marL="0">
+              <a:buNone/>
+            </a:pPr>
+            <a:r>
+              <a:rPr lang="en-US" sz="1500" i="1" dirty="0">
+                <a:solidFill>
+                  <a:srgbClr val="5B6570"/>
+                </a:solidFill>
+                <a:latin typeface="Calibri" pitchFamily="34" charset="0"/>
+                <a:ea typeface="Calibri" pitchFamily="34" charset="-122"/>
+                <a:cs typeface="Calibri" pitchFamily="34" charset="-120"/>
+              </a:rPr>
+              <a:t>Sometimes the workload can’t come to AWS — so AWS goes to it.</a:t>
+            </a:r>
+            <a:endParaRPr lang="en-US" sz="1500" dirty="0"/>
+          </a:p>
+        </p:txBody>
+      </p:sp>
+      <p:sp>
+        <p:nvSpPr>
+          <p:cNvPr id="5" name="Shape 3"/>
+          <p:cNvSpPr/>
+          <p:nvPr/>
+        </p:nvSpPr>
+        <p:spPr>
+          <a:xfrm>
+            <a:off x="640080" y="1965960"/>
+            <a:ext cx="3383280" cy="2834640"/>
+          </a:xfrm>
+          <a:prstGeom prst="roundRect">
+            <a:avLst>
+              <a:gd name="adj" fmla="val 3871"/>
+            </a:avLst>
+          </a:prstGeom>
+          <a:solidFill>
+            <a:srgbClr val="FFFFFF"/>
+          </a:solidFill>
+          <a:ln w="12700">
+            <a:solidFill>
+              <a:srgbClr val="DCE1E6"/>
+            </a:solidFill>
+            <a:prstDash val="solid"/>
+          </a:ln>
+          <a:effectLst>
+            <a:outerShdw sx="100000" sy="100000" kx="0" ky="0" algn="bl" rotWithShape="0" blurRad="101600" dist="38100" dir="5400000">
+              <a:srgbClr val="C6CDD4">
+                <a:alpha val="50000"/>
+              </a:srgbClr>
+            </a:outerShdw>
+          </a:effectLst>
+        </p:spPr>
+      </p:sp>
+      <p:sp>
+        <p:nvSpPr>
+          <p:cNvPr id="6" name="Shape 4"/>
+          <p:cNvSpPr/>
+          <p:nvPr/>
+        </p:nvSpPr>
+        <p:spPr>
+          <a:xfrm>
+            <a:off x="640080" y="1965960"/>
+            <a:ext cx="3383280" cy="146304"/>
+          </a:xfrm>
+          <a:prstGeom prst="roundRect">
+            <a:avLst>
+              <a:gd name="adj" fmla="val 12500"/>
+            </a:avLst>
+          </a:prstGeom>
+          <a:solidFill>
+            <a:srgbClr val="EC7211"/>
+          </a:solidFill>
+          <a:ln/>
+        </p:spPr>
+      </p:sp>
+      <p:sp>
+        <p:nvSpPr>
+          <p:cNvPr id="7" name="Text 5"/>
+          <p:cNvSpPr/>
+          <p:nvPr/>
+        </p:nvSpPr>
+        <p:spPr>
+          <a:xfrm>
+            <a:off x="960120" y="2331720"/>
+            <a:ext cx="2743200" cy="457200"/>
+          </a:xfrm>
+          <a:prstGeom prst="rect">
+            <a:avLst/>
+          </a:prstGeom>
+          <a:noFill/>
+          <a:ln/>
+        </p:spPr>
+        <p:txBody>
+          <a:bodyPr wrap="square" rtlCol="0" anchor="ctr"/>
+          <a:lstStyle/>
+          <a:p>
+            <a:pPr indent="0" marL="0">
+              <a:buNone/>
+            </a:pPr>
+            <a:r>
+              <a:rPr lang="en-US" sz="1800" b="1" dirty="0">
+                <a:solidFill>
+                  <a:srgbClr val="EC7211"/>
+                </a:solidFill>
+                <a:latin typeface="Calibri" pitchFamily="34" charset="0"/>
+                <a:ea typeface="Calibri" pitchFamily="34" charset="-122"/>
+                <a:cs typeface="Calibri" pitchFamily="34" charset="-120"/>
+              </a:rPr>
+              <a:t>1 · What It Is</a:t>
+            </a:r>
+            <a:endParaRPr lang="en-US" sz="1800" dirty="0"/>
+          </a:p>
+        </p:txBody>
+      </p:sp>
+      <p:sp>
+        <p:nvSpPr>
+          <p:cNvPr id="8" name="Text 6"/>
+          <p:cNvSpPr/>
+          <p:nvPr/>
+        </p:nvSpPr>
+        <p:spPr>
+          <a:xfrm>
+            <a:off x="960120" y="2834640"/>
+            <a:ext cx="2743200" cy="1783080"/>
+          </a:xfrm>
+          <a:prstGeom prst="rect">
+            <a:avLst/>
+          </a:prstGeom>
+          <a:noFill/>
+          <a:ln/>
+        </p:spPr>
+        <p:txBody>
+          <a:bodyPr wrap="square" rtlCol="0" anchor="ctr"/>
+          <a:lstStyle/>
+          <a:p>
+            <a:pPr indent="0" marL="0">
+              <a:lnSpc>
+                <a:spcPct val="105000"/>
+              </a:lnSpc>
+              <a:buNone/>
+            </a:pPr>
+            <a:r>
+              <a:rPr lang="en-US" sz="1350" dirty="0">
+                <a:solidFill>
+                  <a:srgbClr val="5B6570"/>
+                </a:solidFill>
+                <a:latin typeface="Calibri" pitchFamily="34" charset="0"/>
+                <a:ea typeface="Calibri" pitchFamily="34" charset="-122"/>
+                <a:cs typeface="Calibri" pitchFamily="34" charset="-120"/>
+              </a:rPr>
+              <a:t>Actual AWS hardware, installed in your own data center or facility, managed by AWS.</a:t>
+            </a:r>
+            <a:endParaRPr lang="en-US" sz="1350" dirty="0"/>
+          </a:p>
+        </p:txBody>
+      </p:sp>
+      <p:sp>
+        <p:nvSpPr>
+          <p:cNvPr id="9" name="Shape 7"/>
+          <p:cNvSpPr/>
+          <p:nvPr/>
+        </p:nvSpPr>
+        <p:spPr>
+          <a:xfrm>
+            <a:off x="4343400" y="1965960"/>
+            <a:ext cx="3383280" cy="2834640"/>
+          </a:xfrm>
+          <a:prstGeom prst="roundRect">
+            <a:avLst>
+              <a:gd name="adj" fmla="val 3871"/>
+            </a:avLst>
+          </a:prstGeom>
+          <a:solidFill>
+            <a:srgbClr val="FFFFFF"/>
+          </a:solidFill>
+          <a:ln w="12700">
+            <a:solidFill>
+              <a:srgbClr val="DCE1E6"/>
+            </a:solidFill>
+            <a:prstDash val="solid"/>
+          </a:ln>
+          <a:effectLst>
+            <a:outerShdw sx="100000" sy="100000" kx="0" ky="0" algn="bl" rotWithShape="0" blurRad="101600" dist="38100" dir="5400000">
+              <a:srgbClr val="C6CDD4">
+                <a:alpha val="50000"/>
+              </a:srgbClr>
+            </a:outerShdw>
+          </a:effectLst>
+        </p:spPr>
+      </p:sp>
+      <p:sp>
+        <p:nvSpPr>
+          <p:cNvPr id="10" name="Shape 8"/>
+          <p:cNvSpPr/>
+          <p:nvPr/>
+        </p:nvSpPr>
+        <p:spPr>
+          <a:xfrm>
+            <a:off x="4343400" y="1965960"/>
+            <a:ext cx="3383280" cy="146304"/>
+          </a:xfrm>
+          <a:prstGeom prst="roundRect">
+            <a:avLst>
+              <a:gd name="adj" fmla="val 12500"/>
+            </a:avLst>
+          </a:prstGeom>
+          <a:solidFill>
+            <a:srgbClr val="1E8FA5"/>
+          </a:solidFill>
+          <a:ln/>
+        </p:spPr>
+      </p:sp>
+      <p:sp>
+        <p:nvSpPr>
+          <p:cNvPr id="11" name="Text 9"/>
+          <p:cNvSpPr/>
+          <p:nvPr/>
+        </p:nvSpPr>
+        <p:spPr>
+          <a:xfrm>
+            <a:off x="4663440" y="2331720"/>
+            <a:ext cx="2743200" cy="457200"/>
+          </a:xfrm>
+          <a:prstGeom prst="rect">
+            <a:avLst/>
+          </a:prstGeom>
+          <a:noFill/>
+          <a:ln/>
+        </p:spPr>
+        <p:txBody>
+          <a:bodyPr wrap="square" rtlCol="0" anchor="ctr"/>
+          <a:lstStyle/>
+          <a:p>
+            <a:pPr indent="0" marL="0">
+              <a:buNone/>
+            </a:pPr>
+            <a:r>
+              <a:rPr lang="en-US" sz="1800" b="1" dirty="0">
+                <a:solidFill>
+                  <a:srgbClr val="1E8FA5"/>
+                </a:solidFill>
+                <a:latin typeface="Calibri" pitchFamily="34" charset="0"/>
+                <a:ea typeface="Calibri" pitchFamily="34" charset="-122"/>
+                <a:cs typeface="Calibri" pitchFamily="34" charset="-120"/>
+              </a:rPr>
+              <a:t>2 · How It Connects</a:t>
+            </a:r>
+            <a:endParaRPr lang="en-US" sz="1800" dirty="0"/>
+          </a:p>
+        </p:txBody>
+      </p:sp>
+      <p:sp>
+        <p:nvSpPr>
+          <p:cNvPr id="12" name="Text 10"/>
+          <p:cNvSpPr/>
+          <p:nvPr/>
+        </p:nvSpPr>
+        <p:spPr>
+          <a:xfrm>
+            <a:off x="4663440" y="2834640"/>
+            <a:ext cx="2743200" cy="1783080"/>
+          </a:xfrm>
+          <a:prstGeom prst="rect">
+            <a:avLst/>
+          </a:prstGeom>
+          <a:noFill/>
+          <a:ln/>
+        </p:spPr>
+        <p:txBody>
+          <a:bodyPr wrap="square" rtlCol="0" anchor="ctr"/>
+          <a:lstStyle/>
+          <a:p>
+            <a:pPr indent="0" marL="0">
+              <a:lnSpc>
+                <a:spcPct val="105000"/>
+              </a:lnSpc>
+              <a:buNone/>
+            </a:pPr>
+            <a:r>
+              <a:rPr lang="en-US" sz="1350" dirty="0">
+                <a:solidFill>
+                  <a:srgbClr val="5B6570"/>
+                </a:solidFill>
+                <a:latin typeface="Calibri" pitchFamily="34" charset="0"/>
+                <a:ea typeface="Calibri" pitchFamily="34" charset="-122"/>
+                <a:cs typeface="Calibri" pitchFamily="34" charset="-120"/>
+              </a:rPr>
+              <a:t>Runs the same APIs and services as a Region, linked back to AWS over a network connection.</a:t>
+            </a:r>
+            <a:endParaRPr lang="en-US" sz="1350" dirty="0"/>
+          </a:p>
+        </p:txBody>
+      </p:sp>
+      <p:sp>
+        <p:nvSpPr>
+          <p:cNvPr id="13" name="Shape 11"/>
+          <p:cNvSpPr/>
+          <p:nvPr/>
+        </p:nvSpPr>
+        <p:spPr>
+          <a:xfrm>
+            <a:off x="8046720" y="1965960"/>
+            <a:ext cx="3383280" cy="2834640"/>
+          </a:xfrm>
+          <a:prstGeom prst="roundRect">
+            <a:avLst>
+              <a:gd name="adj" fmla="val 3871"/>
+            </a:avLst>
+          </a:prstGeom>
+          <a:solidFill>
+            <a:srgbClr val="FFFFFF"/>
+          </a:solidFill>
+          <a:ln w="12700">
+            <a:solidFill>
+              <a:srgbClr val="DCE1E6"/>
+            </a:solidFill>
+            <a:prstDash val="solid"/>
+          </a:ln>
+          <a:effectLst>
+            <a:outerShdw sx="100000" sy="100000" kx="0" ky="0" algn="bl" rotWithShape="0" blurRad="101600" dist="38100" dir="5400000">
+              <a:srgbClr val="C6CDD4">
+                <a:alpha val="50000"/>
+              </a:srgbClr>
+            </a:outerShdw>
+          </a:effectLst>
+        </p:spPr>
+      </p:sp>
+      <p:sp>
+        <p:nvSpPr>
+          <p:cNvPr id="14" name="Shape 12"/>
+          <p:cNvSpPr/>
+          <p:nvPr/>
+        </p:nvSpPr>
+        <p:spPr>
+          <a:xfrm>
+            <a:off x="8046720" y="1965960"/>
+            <a:ext cx="3383280" cy="146304"/>
+          </a:xfrm>
+          <a:prstGeom prst="roundRect">
+            <a:avLst>
+              <a:gd name="adj" fmla="val 12500"/>
+            </a:avLst>
+          </a:prstGeom>
+          <a:solidFill>
+            <a:srgbClr val="C0392B"/>
+          </a:solidFill>
+          <a:ln/>
+        </p:spPr>
+      </p:sp>
+      <p:sp>
+        <p:nvSpPr>
+          <p:cNvPr id="15" name="Text 13"/>
+          <p:cNvSpPr/>
+          <p:nvPr/>
+        </p:nvSpPr>
+        <p:spPr>
+          <a:xfrm>
+            <a:off x="8366760" y="2331720"/>
+            <a:ext cx="2743200" cy="457200"/>
+          </a:xfrm>
+          <a:prstGeom prst="rect">
+            <a:avLst/>
+          </a:prstGeom>
+          <a:noFill/>
+          <a:ln/>
+        </p:spPr>
+        <p:txBody>
+          <a:bodyPr wrap="square" rtlCol="0" anchor="ctr"/>
+          <a:lstStyle/>
+          <a:p>
+            <a:pPr indent="0" marL="0">
+              <a:buNone/>
+            </a:pPr>
+            <a:r>
+              <a:rPr lang="en-US" sz="1800" b="1" dirty="0">
+                <a:solidFill>
+                  <a:srgbClr val="C0392B"/>
+                </a:solidFill>
+                <a:latin typeface="Calibri" pitchFamily="34" charset="0"/>
+                <a:ea typeface="Calibri" pitchFamily="34" charset="-122"/>
+                <a:cs typeface="Calibri" pitchFamily="34" charset="-120"/>
+              </a:rPr>
+              <a:t>3 · When You’d Use It</a:t>
+            </a:r>
+            <a:endParaRPr lang="en-US" sz="1800" dirty="0"/>
+          </a:p>
+        </p:txBody>
+      </p:sp>
+      <p:sp>
+        <p:nvSpPr>
+          <p:cNvPr id="16" name="Text 14"/>
+          <p:cNvSpPr/>
+          <p:nvPr/>
+        </p:nvSpPr>
+        <p:spPr>
+          <a:xfrm>
+            <a:off x="8366760" y="2834640"/>
+            <a:ext cx="2743200" cy="1783080"/>
+          </a:xfrm>
+          <a:prstGeom prst="rect">
+            <a:avLst/>
+          </a:prstGeom>
+          <a:noFill/>
+          <a:ln/>
+        </p:spPr>
+        <p:txBody>
+          <a:bodyPr wrap="square" rtlCol="0" anchor="ctr"/>
+          <a:lstStyle/>
+          <a:p>
+            <a:pPr indent="0" marL="0">
+              <a:lnSpc>
+                <a:spcPct val="105000"/>
+              </a:lnSpc>
+              <a:buNone/>
+            </a:pPr>
+            <a:r>
+              <a:rPr lang="en-US" sz="1350" dirty="0">
+                <a:solidFill>
+                  <a:srgbClr val="5B6570"/>
+                </a:solidFill>
+                <a:latin typeface="Calibri" pitchFamily="34" charset="0"/>
+                <a:ea typeface="Calibri" pitchFamily="34" charset="-122"/>
+                <a:cs typeface="Calibri" pitchFamily="34" charset="-120"/>
+              </a:rPr>
+              <a:t>Ultra-low latency on-site, local data processing needs, or workloads that legally can’t leave the building.</a:t>
+            </a:r>
+            <a:endParaRPr lang="en-US" sz="1350" dirty="0"/>
+          </a:p>
+        </p:txBody>
+      </p:sp>
+      <p:sp>
+        <p:nvSpPr>
+          <p:cNvPr id="17" name="Shape 15"/>
+          <p:cNvSpPr/>
+          <p:nvPr/>
+        </p:nvSpPr>
+        <p:spPr>
+          <a:xfrm>
+            <a:off x="640080" y="5029200"/>
+            <a:ext cx="10908792" cy="914400"/>
+          </a:xfrm>
+          <a:prstGeom prst="roundRect">
+            <a:avLst>
+              <a:gd name="adj" fmla="val 10000"/>
+            </a:avLst>
+          </a:prstGeom>
+          <a:solidFill>
+            <a:srgbClr val="232F3E"/>
+          </a:solidFill>
+          <a:ln/>
+        </p:spPr>
+      </p:sp>
+      <p:sp>
+        <p:nvSpPr>
+          <p:cNvPr id="18" name="Text 16"/>
+          <p:cNvSpPr/>
+          <p:nvPr/>
+        </p:nvSpPr>
+        <p:spPr>
+          <a:xfrm>
+            <a:off x="1051560" y="5212080"/>
+            <a:ext cx="10085832" cy="640080"/>
+          </a:xfrm>
+          <a:prstGeom prst="rect">
+            <a:avLst/>
+          </a:prstGeom>
+          <a:noFill/>
+          <a:ln/>
+        </p:spPr>
+        <p:txBody>
+          <a:bodyPr wrap="square" rtlCol="0" anchor="ctr"/>
+          <a:lstStyle/>
+          <a:p>
+            <a:pPr indent="0" marL="0">
+              <a:lnSpc>
+                <a:spcPct val="103000"/>
+              </a:lnSpc>
+              <a:buNone/>
+            </a:pPr>
+            <a:r>
+              <a:rPr lang="en-US" sz="1500" b="1" dirty="0">
+                <a:solidFill>
+                  <a:srgbClr val="FF9900"/>
+                </a:solidFill>
+                <a:latin typeface="Calibri" pitchFamily="34" charset="0"/>
+                <a:ea typeface="Calibri" pitchFamily="34" charset="-122"/>
+                <a:cs typeface="Calibri" pitchFamily="34" charset="-120"/>
+              </a:rPr>
+              <a:t>The exam angle:  </a:t>
+            </a:r>
+            <a:pPr indent="0" marL="0">
+              <a:lnSpc>
+                <a:spcPct val="103000"/>
+              </a:lnSpc>
+              <a:buNone/>
+            </a:pPr>
+            <a:r>
+              <a:rPr lang="en-US" sz="1500" dirty="0">
+                <a:solidFill>
+                  <a:srgbClr val="D6DEE7"/>
+                </a:solidFill>
+                <a:latin typeface="Calibri" pitchFamily="34" charset="0"/>
+                <a:ea typeface="Calibri" pitchFamily="34" charset="-122"/>
+                <a:cs typeface="Calibri" pitchFamily="34" charset="-120"/>
+              </a:rPr>
+              <a:t>Outposts is the answer whenever a scenario says data or processing legally or physically cannot leave a specific building — everything else (Local Zones, Wavelength, Regions) assumes it’s fine to leave the premises.</a:t>
+            </a:r>
+            <a:endParaRPr lang="en-US" sz="1500" dirty="0"/>
+          </a:p>
+        </p:txBody>
+      </p:sp>
+      <p:sp>
+        <p:nvSpPr>
+          <p:cNvPr id="19" name="Text 17"/>
+          <p:cNvSpPr/>
+          <p:nvPr/>
+        </p:nvSpPr>
+        <p:spPr>
+          <a:xfrm>
+            <a:off x="640080" y="6473952"/>
+            <a:ext cx="5943600" cy="274320"/>
+          </a:xfrm>
+          <a:prstGeom prst="rect">
+            <a:avLst/>
+          </a:prstGeom>
+          <a:noFill/>
+          <a:ln/>
+        </p:spPr>
+        <p:txBody>
+          <a:bodyPr wrap="square" rtlCol="0" anchor="ctr"/>
+          <a:lstStyle/>
+          <a:p>
+            <a:pPr indent="0" marL="0">
+              <a:buNone/>
+            </a:pPr>
+            <a:r>
+              <a:rPr lang="en-US" sz="900" dirty="0">
+                <a:solidFill>
+                  <a:srgbClr val="5B6570"/>
+                </a:solidFill>
+                <a:latin typeface="Calibri" pitchFamily="34" charset="0"/>
+                <a:ea typeface="Calibri" pitchFamily="34" charset="-122"/>
+                <a:cs typeface="Calibri" pitchFamily="34" charset="-120"/>
+              </a:rPr>
+              <a:t>AWS SAA-A  ·  Lecture 3  ·  AWS Global Infrastructure Overview</a:t>
+            </a:r>
+            <a:endParaRPr lang="en-US" sz="900" dirty="0"/>
+          </a:p>
+        </p:txBody>
+      </p:sp>
+      <p:sp>
+        <p:nvSpPr>
+          <p:cNvPr id="20" name="Text 18"/>
+          <p:cNvSpPr/>
+          <p:nvPr/>
+        </p:nvSpPr>
+        <p:spPr>
+          <a:xfrm>
+            <a:off x="11000232" y="6473952"/>
+            <a:ext cx="548640" cy="274320"/>
+          </a:xfrm>
+          <a:prstGeom prst="rect">
+            <a:avLst/>
+          </a:prstGeom>
+          <a:noFill/>
+          <a:ln/>
+        </p:spPr>
+        <p:txBody>
+          <a:bodyPr wrap="square" rtlCol="0" anchor="ctr"/>
+          <a:lstStyle/>
+          <a:p>
+            <a:pPr algn="r" indent="0" marL="0">
+              <a:buNone/>
+            </a:pPr>
+            <a:r>
+              <a:rPr lang="en-US" sz="900" dirty="0">
+                <a:solidFill>
+                  <a:srgbClr val="5B6570"/>
+                </a:solidFill>
+                <a:latin typeface="Calibri" pitchFamily="34" charset="0"/>
+                <a:ea typeface="Calibri" pitchFamily="34" charset="-122"/>
+                <a:cs typeface="Calibri" pitchFamily="34" charset="-120"/>
+              </a:rPr>
+              <a:t>10</a:t>
+            </a:r>
+            <a:endParaRPr lang="en-US" sz="900" dirty="0"/>
+          </a:p>
+        </p:txBody>
+      </p:sp>
+    </p:spTree>
+  </p:cSld>
+  <p:clrMapOvr>
+    <a:masterClrMapping/>
+  </p:clrMapOvr>
+</p:sld>
+</file>
+
+<file path=ppt/slides/slide34.xml><?xml version="1.0" encoding="utf-8"?>
+<p:sld xmlns:a="http://schemas.openxmlformats.org/drawingml/2006/main" xmlns:r="http://schemas.openxmlformats.org/officeDocument/2006/relationships" xmlns:p="http://schemas.openxmlformats.org/presentationml/2006/main">
+  <p:cSld name="Slide 19">
+    <p:bg>
+      <p:bgPr>
+        <a:solidFill>
+          <a:srgbClr val="F4F6F8"/>
+        </a:solidFill>
+      </p:bgPr>
+    </p:bg>
+    <p:spTree>
+      <p:nvGrpSpPr>
+        <p:cNvPr id="1" name=""/>
+        <p:cNvGrpSpPr/>
+        <p:nvPr/>
+      </p:nvGrpSpPr>
+      <p:grpSpPr>
+        <a:xfrm>
+          <a:off x="0" y="0"/>
+          <a:ext cx="0" cy="0"/>
+          <a:chOff x="0" y="0"/>
+          <a:chExt cx="0" cy="0"/>
+        </a:xfrm>
+      </p:grpSpPr>
+      <p:sp>
+        <p:nvSpPr>
+          <p:cNvPr id="2" name="Text 0"/>
+          <p:cNvSpPr/>
+          <p:nvPr/>
+        </p:nvSpPr>
+        <p:spPr>
+          <a:xfrm>
+            <a:off x="640080" y="457200"/>
+            <a:ext cx="10908792" cy="274320"/>
+          </a:xfrm>
+          <a:prstGeom prst="rect">
+            <a:avLst/>
+          </a:prstGeom>
+          <a:noFill/>
+          <a:ln/>
+        </p:spPr>
+        <p:txBody>
+          <a:bodyPr wrap="square" rtlCol="0" anchor="ctr"/>
+          <a:lstStyle/>
+          <a:p>
+            <a:pPr indent="0" marL="0">
+              <a:buNone/>
+            </a:pPr>
+            <a:r>
+              <a:rPr lang="en-US" sz="1200" b="1" spc="200" kern="0" dirty="0">
+                <a:solidFill>
+                  <a:srgbClr val="EC7211"/>
+                </a:solidFill>
+                <a:latin typeface="Calibri" pitchFamily="34" charset="0"/>
+                <a:ea typeface="Calibri" pitchFamily="34" charset="-122"/>
+                <a:cs typeface="Calibri" pitchFamily="34" charset="-120"/>
+              </a:rPr>
+              <a:t>THE BIG PICTURE, IN NUMBERS</a:t>
+            </a:r>
+            <a:endParaRPr lang="en-US" sz="1200" dirty="0"/>
+          </a:p>
+        </p:txBody>
+      </p:sp>
+      <p:sp>
+        <p:nvSpPr>
+          <p:cNvPr id="3" name="Text 1"/>
+          <p:cNvSpPr/>
+          <p:nvPr/>
+        </p:nvSpPr>
+        <p:spPr>
+          <a:xfrm>
+            <a:off x="640080" y="731520"/>
+            <a:ext cx="10908792" cy="640080"/>
+          </a:xfrm>
+          <a:prstGeom prst="rect">
+            <a:avLst/>
+          </a:prstGeom>
+          <a:noFill/>
+          <a:ln/>
+        </p:spPr>
+        <p:txBody>
+          <a:bodyPr wrap="square" rtlCol="0" anchor="ctr"/>
+          <a:lstStyle/>
+          <a:p>
+            <a:pPr indent="0" marL="0">
+              <a:buNone/>
+            </a:pPr>
+            <a:r>
+              <a:rPr lang="en-US" sz="3200" b="1" dirty="0">
+                <a:solidFill>
+                  <a:srgbClr val="232F3E"/>
+                </a:solidFill>
+                <a:latin typeface="Calibri" pitchFamily="34" charset="0"/>
+                <a:ea typeface="Calibri" pitchFamily="34" charset="-122"/>
+                <a:cs typeface="Calibri" pitchFamily="34" charset="-120"/>
+              </a:rPr>
+              <a:t>Global Infrastructure by the Numbers</a:t>
+            </a:r>
+            <a:endParaRPr lang="en-US" sz="3200" dirty="0"/>
+          </a:p>
+        </p:txBody>
+      </p:sp>
+      <p:sp>
+        <p:nvSpPr>
+          <p:cNvPr id="4" name="Text 2"/>
+          <p:cNvSpPr/>
+          <p:nvPr/>
+        </p:nvSpPr>
+        <p:spPr>
+          <a:xfrm>
+            <a:off x="640080" y="1417320"/>
+            <a:ext cx="10908792" cy="365760"/>
+          </a:xfrm>
+          <a:prstGeom prst="rect">
+            <a:avLst/>
+          </a:prstGeom>
+          <a:noFill/>
+          <a:ln/>
+        </p:spPr>
+        <p:txBody>
+          <a:bodyPr wrap="square" rtlCol="0" anchor="ctr"/>
+          <a:lstStyle/>
+          <a:p>
+            <a:pPr indent="0" marL="0">
+              <a:buNone/>
+            </a:pPr>
+            <a:r>
+              <a:rPr lang="en-US" sz="1500" i="1" dirty="0">
+                <a:solidFill>
+                  <a:srgbClr val="5B6570"/>
+                </a:solidFill>
+                <a:latin typeface="Calibri" pitchFamily="34" charset="0"/>
+                <a:ea typeface="Calibri" pitchFamily="34" charset="-122"/>
+                <a:cs typeface="Calibri" pitchFamily="34" charset="-120"/>
+              </a:rPr>
+              <a:t>Five layers we’ve covered tonight, and roughly how AWS’s footprint breaks down. Exact counts change — treat these as orders of magnitude.</a:t>
+            </a:r>
+            <a:endParaRPr lang="en-US" sz="1500" dirty="0"/>
+          </a:p>
+        </p:txBody>
+      </p:sp>
+      <p:sp>
+        <p:nvSpPr>
+          <p:cNvPr id="5" name="Shape 3"/>
+          <p:cNvSpPr/>
+          <p:nvPr/>
+        </p:nvSpPr>
+        <p:spPr>
+          <a:xfrm>
+            <a:off x="640080" y="2011680"/>
+            <a:ext cx="2035454" cy="2834640"/>
+          </a:xfrm>
+          <a:prstGeom prst="roundRect">
+            <a:avLst>
+              <a:gd name="adj" fmla="val 4492"/>
+            </a:avLst>
+          </a:prstGeom>
+          <a:solidFill>
+            <a:srgbClr val="FFFFFF"/>
+          </a:solidFill>
+          <a:ln w="12700">
+            <a:solidFill>
+              <a:srgbClr val="DCE1E6"/>
+            </a:solidFill>
+            <a:prstDash val="solid"/>
+          </a:ln>
+          <a:effectLst>
+            <a:outerShdw sx="100000" sy="100000" kx="0" ky="0" algn="bl" rotWithShape="0" blurRad="88900" dist="25400" dir="5400000">
+              <a:srgbClr val="CBD2D8">
+                <a:alpha val="50000"/>
+              </a:srgbClr>
+            </a:outerShdw>
+          </a:effectLst>
+        </p:spPr>
+      </p:sp>
+      <p:sp>
+        <p:nvSpPr>
+          <p:cNvPr id="6" name="Shape 4"/>
+          <p:cNvSpPr/>
+          <p:nvPr/>
+        </p:nvSpPr>
+        <p:spPr>
+          <a:xfrm>
+            <a:off x="640080" y="2011680"/>
+            <a:ext cx="2035454" cy="146304"/>
+          </a:xfrm>
+          <a:prstGeom prst="roundRect">
+            <a:avLst>
+              <a:gd name="adj" fmla="val 12500"/>
+            </a:avLst>
+          </a:prstGeom>
+          <a:solidFill>
+            <a:srgbClr val="1F8A38"/>
+          </a:solidFill>
+          <a:ln/>
+        </p:spPr>
+      </p:sp>
+      <p:sp>
+        <p:nvSpPr>
+          <p:cNvPr id="7" name="Text 5"/>
+          <p:cNvSpPr/>
+          <p:nvPr/>
+        </p:nvSpPr>
+        <p:spPr>
+          <a:xfrm>
+            <a:off x="868680" y="2377440"/>
+            <a:ext cx="1578254" cy="685800"/>
+          </a:xfrm>
+          <a:prstGeom prst="rect">
+            <a:avLst/>
+          </a:prstGeom>
+          <a:noFill/>
+          <a:ln/>
+        </p:spPr>
+        <p:txBody>
+          <a:bodyPr wrap="square" rtlCol="0" anchor="ctr"/>
+          <a:lstStyle/>
+          <a:p>
+            <a:pPr indent="0" marL="0">
+              <a:lnSpc>
+                <a:spcPct val="95000"/>
+              </a:lnSpc>
+              <a:buNone/>
+            </a:pPr>
+            <a:r>
+              <a:rPr lang="en-US" sz="1550" b="1" dirty="0">
+                <a:solidFill>
+                  <a:srgbClr val="1F8A38"/>
+                </a:solidFill>
+                <a:latin typeface="Calibri" pitchFamily="34" charset="0"/>
+                <a:ea typeface="Calibri" pitchFamily="34" charset="-122"/>
+                <a:cs typeface="Calibri" pitchFamily="34" charset="-120"/>
+              </a:rPr>
+              <a:t>Regions</a:t>
+            </a:r>
+            <a:endParaRPr lang="en-US" sz="1550" dirty="0"/>
+          </a:p>
+        </p:txBody>
+      </p:sp>
+      <p:sp>
+        <p:nvSpPr>
+          <p:cNvPr id="8" name="Text 6"/>
+          <p:cNvSpPr/>
+          <p:nvPr/>
+        </p:nvSpPr>
+        <p:spPr>
+          <a:xfrm>
+            <a:off x="868680" y="3154680"/>
+            <a:ext cx="1578254" cy="1371600"/>
+          </a:xfrm>
+          <a:prstGeom prst="rect">
+            <a:avLst/>
+          </a:prstGeom>
+          <a:noFill/>
+          <a:ln/>
+        </p:spPr>
+        <p:txBody>
+          <a:bodyPr wrap="square" rtlCol="0" anchor="ctr"/>
+          <a:lstStyle/>
+          <a:p>
+            <a:pPr indent="0" marL="0">
+              <a:lnSpc>
+                <a:spcPct val="105000"/>
+              </a:lnSpc>
+              <a:buNone/>
+            </a:pPr>
+            <a:r>
+              <a:rPr lang="en-US" sz="1250" dirty="0">
+                <a:solidFill>
+                  <a:srgbClr val="5B6570"/>
+                </a:solidFill>
+                <a:latin typeface="Calibri" pitchFamily="34" charset="0"/>
+                <a:ea typeface="Calibri" pitchFamily="34" charset="-122"/>
+                <a:cs typeface="Calibri" pitchFamily="34" charset="-120"/>
+              </a:rPr>
+              <a:t>30+ separate geographic areas worldwide, and still growing.</a:t>
+            </a:r>
+            <a:endParaRPr lang="en-US" sz="1250" dirty="0"/>
+          </a:p>
+        </p:txBody>
+      </p:sp>
+      <p:sp>
+        <p:nvSpPr>
+          <p:cNvPr id="9" name="Shape 7"/>
+          <p:cNvSpPr/>
+          <p:nvPr/>
+        </p:nvSpPr>
+        <p:spPr>
+          <a:xfrm>
+            <a:off x="2858414" y="2011680"/>
+            <a:ext cx="2035454" cy="2834640"/>
+          </a:xfrm>
+          <a:prstGeom prst="roundRect">
+            <a:avLst>
+              <a:gd name="adj" fmla="val 4492"/>
+            </a:avLst>
+          </a:prstGeom>
+          <a:solidFill>
+            <a:srgbClr val="FFFFFF"/>
+          </a:solidFill>
+          <a:ln w="12700">
+            <a:solidFill>
+              <a:srgbClr val="DCE1E6"/>
+            </a:solidFill>
+            <a:prstDash val="solid"/>
+          </a:ln>
+          <a:effectLst>
+            <a:outerShdw sx="100000" sy="100000" kx="0" ky="0" algn="bl" rotWithShape="0" blurRad="88900" dist="25400" dir="5400000">
+              <a:srgbClr val="CBD2D8">
+                <a:alpha val="50000"/>
+              </a:srgbClr>
+            </a:outerShdw>
+          </a:effectLst>
+        </p:spPr>
+      </p:sp>
+      <p:sp>
+        <p:nvSpPr>
+          <p:cNvPr id="10" name="Shape 8"/>
+          <p:cNvSpPr/>
+          <p:nvPr/>
+        </p:nvSpPr>
+        <p:spPr>
+          <a:xfrm>
+            <a:off x="2858414" y="2011680"/>
+            <a:ext cx="2035454" cy="146304"/>
+          </a:xfrm>
+          <a:prstGeom prst="roundRect">
+            <a:avLst>
+              <a:gd name="adj" fmla="val 12500"/>
+            </a:avLst>
+          </a:prstGeom>
+          <a:solidFill>
+            <a:srgbClr val="1E8FA5"/>
+          </a:solidFill>
+          <a:ln/>
+        </p:spPr>
+      </p:sp>
+      <p:sp>
+        <p:nvSpPr>
+          <p:cNvPr id="11" name="Text 9"/>
+          <p:cNvSpPr/>
+          <p:nvPr/>
+        </p:nvSpPr>
+        <p:spPr>
+          <a:xfrm>
+            <a:off x="3087014" y="2377440"/>
+            <a:ext cx="1578254" cy="685800"/>
+          </a:xfrm>
+          <a:prstGeom prst="rect">
+            <a:avLst/>
+          </a:prstGeom>
+          <a:noFill/>
+          <a:ln/>
+        </p:spPr>
+        <p:txBody>
+          <a:bodyPr wrap="square" rtlCol="0" anchor="ctr"/>
+          <a:lstStyle/>
+          <a:p>
+            <a:pPr indent="0" marL="0">
+              <a:lnSpc>
+                <a:spcPct val="95000"/>
+              </a:lnSpc>
+              <a:buNone/>
+            </a:pPr>
+            <a:r>
+              <a:rPr lang="en-US" sz="1550" b="1" dirty="0">
+                <a:solidFill>
+                  <a:srgbClr val="1E8FA5"/>
+                </a:solidFill>
+                <a:latin typeface="Calibri" pitchFamily="34" charset="0"/>
+                <a:ea typeface="Calibri" pitchFamily="34" charset="-122"/>
+                <a:cs typeface="Calibri" pitchFamily="34" charset="-120"/>
+              </a:rPr>
+              <a:t>Availability Zones</a:t>
+            </a:r>
+            <a:endParaRPr lang="en-US" sz="1550" dirty="0"/>
+          </a:p>
+        </p:txBody>
+      </p:sp>
+      <p:sp>
+        <p:nvSpPr>
+          <p:cNvPr id="12" name="Text 10"/>
+          <p:cNvSpPr/>
+          <p:nvPr/>
+        </p:nvSpPr>
+        <p:spPr>
+          <a:xfrm>
+            <a:off x="3087014" y="3154680"/>
+            <a:ext cx="1578254" cy="1371600"/>
+          </a:xfrm>
+          <a:prstGeom prst="rect">
+            <a:avLst/>
+          </a:prstGeom>
+          <a:noFill/>
+          <a:ln/>
+        </p:spPr>
+        <p:txBody>
+          <a:bodyPr wrap="square" rtlCol="0" anchor="ctr"/>
+          <a:lstStyle/>
+          <a:p>
+            <a:pPr indent="0" marL="0">
+              <a:lnSpc>
+                <a:spcPct val="105000"/>
+              </a:lnSpc>
+              <a:buNone/>
+            </a:pPr>
+            <a:r>
+              <a:rPr lang="en-US" sz="1250" dirty="0">
+                <a:solidFill>
+                  <a:srgbClr val="5B6570"/>
+                </a:solidFill>
+                <a:latin typeface="Calibri" pitchFamily="34" charset="0"/>
+                <a:ea typeface="Calibri" pitchFamily="34" charset="-122"/>
+                <a:cs typeface="Calibri" pitchFamily="34" charset="-120"/>
+              </a:rPr>
+              <a:t>Typically 3 or more per Region — often 90+ AZs worldwide.</a:t>
+            </a:r>
+            <a:endParaRPr lang="en-US" sz="1250" dirty="0"/>
+          </a:p>
+        </p:txBody>
+      </p:sp>
+      <p:sp>
+        <p:nvSpPr>
+          <p:cNvPr id="13" name="Shape 11"/>
+          <p:cNvSpPr/>
+          <p:nvPr/>
+        </p:nvSpPr>
+        <p:spPr>
+          <a:xfrm>
+            <a:off x="5076749" y="2011680"/>
+            <a:ext cx="2035454" cy="2834640"/>
+          </a:xfrm>
+          <a:prstGeom prst="roundRect">
+            <a:avLst>
+              <a:gd name="adj" fmla="val 4492"/>
+            </a:avLst>
+          </a:prstGeom>
+          <a:solidFill>
+            <a:srgbClr val="FFFFFF"/>
+          </a:solidFill>
+          <a:ln w="12700">
+            <a:solidFill>
+              <a:srgbClr val="DCE1E6"/>
+            </a:solidFill>
+            <a:prstDash val="solid"/>
+          </a:ln>
+          <a:effectLst>
+            <a:outerShdw sx="100000" sy="100000" kx="0" ky="0" algn="bl" rotWithShape="0" blurRad="88900" dist="25400" dir="5400000">
+              <a:srgbClr val="CBD2D8">
+                <a:alpha val="50000"/>
+              </a:srgbClr>
+            </a:outerShdw>
+          </a:effectLst>
+        </p:spPr>
+      </p:sp>
+      <p:sp>
+        <p:nvSpPr>
+          <p:cNvPr id="14" name="Shape 12"/>
+          <p:cNvSpPr/>
+          <p:nvPr/>
+        </p:nvSpPr>
+        <p:spPr>
+          <a:xfrm>
+            <a:off x="5076749" y="2011680"/>
+            <a:ext cx="2035454" cy="146304"/>
+          </a:xfrm>
+          <a:prstGeom prst="roundRect">
+            <a:avLst>
+              <a:gd name="adj" fmla="val 12500"/>
+            </a:avLst>
+          </a:prstGeom>
+          <a:solidFill>
+            <a:srgbClr val="C0392B"/>
+          </a:solidFill>
+          <a:ln/>
+        </p:spPr>
+      </p:sp>
+      <p:sp>
+        <p:nvSpPr>
+          <p:cNvPr id="15" name="Text 13"/>
+          <p:cNvSpPr/>
+          <p:nvPr/>
+        </p:nvSpPr>
+        <p:spPr>
+          <a:xfrm>
+            <a:off x="5305349" y="2377440"/>
+            <a:ext cx="1578254" cy="685800"/>
+          </a:xfrm>
+          <a:prstGeom prst="rect">
+            <a:avLst/>
+          </a:prstGeom>
+          <a:noFill/>
+          <a:ln/>
+        </p:spPr>
+        <p:txBody>
+          <a:bodyPr wrap="square" rtlCol="0" anchor="ctr"/>
+          <a:lstStyle/>
+          <a:p>
+            <a:pPr indent="0" marL="0">
+              <a:lnSpc>
+                <a:spcPct val="95000"/>
+              </a:lnSpc>
+              <a:buNone/>
+            </a:pPr>
+            <a:r>
+              <a:rPr lang="en-US" sz="1550" b="1" dirty="0">
+                <a:solidFill>
+                  <a:srgbClr val="C0392B"/>
+                </a:solidFill>
+                <a:latin typeface="Calibri" pitchFamily="34" charset="0"/>
+                <a:ea typeface="Calibri" pitchFamily="34" charset="-122"/>
+                <a:cs typeface="Calibri" pitchFamily="34" charset="-120"/>
+              </a:rPr>
+              <a:t>Edge Locations</a:t>
+            </a:r>
+            <a:endParaRPr lang="en-US" sz="1550" dirty="0"/>
+          </a:p>
+        </p:txBody>
+      </p:sp>
+      <p:sp>
+        <p:nvSpPr>
+          <p:cNvPr id="16" name="Text 14"/>
+          <p:cNvSpPr/>
+          <p:nvPr/>
+        </p:nvSpPr>
+        <p:spPr>
+          <a:xfrm>
+            <a:off x="5305349" y="3154680"/>
+            <a:ext cx="1578254" cy="1371600"/>
+          </a:xfrm>
+          <a:prstGeom prst="rect">
+            <a:avLst/>
+          </a:prstGeom>
+          <a:noFill/>
+          <a:ln/>
+        </p:spPr>
+        <p:txBody>
+          <a:bodyPr wrap="square" rtlCol="0" anchor="ctr"/>
+          <a:lstStyle/>
+          <a:p>
+            <a:pPr indent="0" marL="0">
+              <a:lnSpc>
+                <a:spcPct val="105000"/>
+              </a:lnSpc>
+              <a:buNone/>
+            </a:pPr>
+            <a:r>
+              <a:rPr lang="en-US" sz="1250" dirty="0">
+                <a:solidFill>
+                  <a:srgbClr val="5B6570"/>
+                </a:solidFill>
+                <a:latin typeface="Calibri" pitchFamily="34" charset="0"/>
+                <a:ea typeface="Calibri" pitchFamily="34" charset="-122"/>
+                <a:cs typeface="Calibri" pitchFamily="34" charset="-120"/>
+              </a:rPr>
+              <a:t>Hundreds of CloudFront caching sites worldwide.</a:t>
+            </a:r>
+            <a:endParaRPr lang="en-US" sz="1250" dirty="0"/>
+          </a:p>
+        </p:txBody>
+      </p:sp>
+      <p:sp>
+        <p:nvSpPr>
+          <p:cNvPr id="17" name="Shape 15"/>
+          <p:cNvSpPr/>
+          <p:nvPr/>
+        </p:nvSpPr>
+        <p:spPr>
+          <a:xfrm>
+            <a:off x="7295083" y="2011680"/>
+            <a:ext cx="2035454" cy="2834640"/>
+          </a:xfrm>
+          <a:prstGeom prst="roundRect">
+            <a:avLst>
+              <a:gd name="adj" fmla="val 4492"/>
+            </a:avLst>
+          </a:prstGeom>
+          <a:solidFill>
+            <a:srgbClr val="FFFFFF"/>
+          </a:solidFill>
+          <a:ln w="12700">
+            <a:solidFill>
+              <a:srgbClr val="DCE1E6"/>
+            </a:solidFill>
+            <a:prstDash val="solid"/>
+          </a:ln>
+          <a:effectLst>
+            <a:outerShdw sx="100000" sy="100000" kx="0" ky="0" algn="bl" rotWithShape="0" blurRad="88900" dist="25400" dir="5400000">
+              <a:srgbClr val="CBD2D8">
+                <a:alpha val="50000"/>
+              </a:srgbClr>
+            </a:outerShdw>
+          </a:effectLst>
+        </p:spPr>
+      </p:sp>
+      <p:sp>
+        <p:nvSpPr>
+          <p:cNvPr id="18" name="Shape 16"/>
+          <p:cNvSpPr/>
+          <p:nvPr/>
+        </p:nvSpPr>
+        <p:spPr>
+          <a:xfrm>
+            <a:off x="7295083" y="2011680"/>
+            <a:ext cx="2035454" cy="146304"/>
+          </a:xfrm>
+          <a:prstGeom prst="roundRect">
+            <a:avLst>
+              <a:gd name="adj" fmla="val 12500"/>
+            </a:avLst>
+          </a:prstGeom>
+          <a:solidFill>
+            <a:srgbClr val="EC7211"/>
+          </a:solidFill>
+          <a:ln/>
+        </p:spPr>
+      </p:sp>
+      <p:sp>
+        <p:nvSpPr>
+          <p:cNvPr id="19" name="Text 17"/>
+          <p:cNvSpPr/>
+          <p:nvPr/>
+        </p:nvSpPr>
+        <p:spPr>
+          <a:xfrm>
+            <a:off x="7523683" y="2377440"/>
+            <a:ext cx="1578254" cy="685800"/>
+          </a:xfrm>
+          <a:prstGeom prst="rect">
+            <a:avLst/>
+          </a:prstGeom>
+          <a:noFill/>
+          <a:ln/>
+        </p:spPr>
+        <p:txBody>
+          <a:bodyPr wrap="square" rtlCol="0" anchor="ctr"/>
+          <a:lstStyle/>
+          <a:p>
+            <a:pPr indent="0" marL="0">
+              <a:lnSpc>
+                <a:spcPct val="95000"/>
+              </a:lnSpc>
+              <a:buNone/>
+            </a:pPr>
+            <a:r>
+              <a:rPr lang="en-US" sz="1550" b="1" dirty="0">
+                <a:solidFill>
+                  <a:srgbClr val="EC7211"/>
+                </a:solidFill>
+                <a:latin typeface="Calibri" pitchFamily="34" charset="0"/>
+                <a:ea typeface="Calibri" pitchFamily="34" charset="-122"/>
+                <a:cs typeface="Calibri" pitchFamily="34" charset="-120"/>
+              </a:rPr>
+              <a:t>Local Zones</a:t>
+            </a:r>
+            <a:endParaRPr lang="en-US" sz="1550" dirty="0"/>
+          </a:p>
+        </p:txBody>
+      </p:sp>
+      <p:sp>
+        <p:nvSpPr>
+          <p:cNvPr id="20" name="Text 18"/>
+          <p:cNvSpPr/>
+          <p:nvPr/>
+        </p:nvSpPr>
+        <p:spPr>
+          <a:xfrm>
+            <a:off x="7523683" y="3154680"/>
+            <a:ext cx="1578254" cy="1371600"/>
+          </a:xfrm>
+          <a:prstGeom prst="rect">
+            <a:avLst/>
+          </a:prstGeom>
+          <a:noFill/>
+          <a:ln/>
+        </p:spPr>
+        <p:txBody>
+          <a:bodyPr wrap="square" rtlCol="0" anchor="ctr"/>
+          <a:lstStyle/>
+          <a:p>
+            <a:pPr indent="0" marL="0">
+              <a:lnSpc>
+                <a:spcPct val="105000"/>
+              </a:lnSpc>
+              <a:buNone/>
+            </a:pPr>
+            <a:r>
+              <a:rPr lang="en-US" sz="1250" dirty="0">
+                <a:solidFill>
+                  <a:srgbClr val="5B6570"/>
+                </a:solidFill>
+                <a:latin typeface="Calibri" pitchFamily="34" charset="0"/>
+                <a:ea typeface="Calibri" pitchFamily="34" charset="-122"/>
+                <a:cs typeface="Calibri" pitchFamily="34" charset="-120"/>
+              </a:rPr>
+              <a:t>Dozens of metro-area extensions, and growing.</a:t>
+            </a:r>
+            <a:endParaRPr lang="en-US" sz="1250" dirty="0"/>
+          </a:p>
+        </p:txBody>
+      </p:sp>
+      <p:sp>
+        <p:nvSpPr>
+          <p:cNvPr id="21" name="Shape 19"/>
+          <p:cNvSpPr/>
+          <p:nvPr/>
+        </p:nvSpPr>
+        <p:spPr>
+          <a:xfrm>
+            <a:off x="9513418" y="2011680"/>
+            <a:ext cx="2035454" cy="2834640"/>
+          </a:xfrm>
+          <a:prstGeom prst="roundRect">
+            <a:avLst>
+              <a:gd name="adj" fmla="val 4492"/>
+            </a:avLst>
+          </a:prstGeom>
+          <a:solidFill>
+            <a:srgbClr val="FFFFFF"/>
+          </a:solidFill>
+          <a:ln w="12700">
+            <a:solidFill>
+              <a:srgbClr val="DCE1E6"/>
+            </a:solidFill>
+            <a:prstDash val="solid"/>
+          </a:ln>
+          <a:effectLst>
+            <a:outerShdw sx="100000" sy="100000" kx="0" ky="0" algn="bl" rotWithShape="0" blurRad="88900" dist="25400" dir="5400000">
+              <a:srgbClr val="CBD2D8">
+                <a:alpha val="50000"/>
+              </a:srgbClr>
+            </a:outerShdw>
+          </a:effectLst>
+        </p:spPr>
+      </p:sp>
+      <p:sp>
+        <p:nvSpPr>
+          <p:cNvPr id="22" name="Shape 20"/>
+          <p:cNvSpPr/>
+          <p:nvPr/>
+        </p:nvSpPr>
+        <p:spPr>
+          <a:xfrm>
+            <a:off x="9513418" y="2011680"/>
+            <a:ext cx="2035454" cy="146304"/>
+          </a:xfrm>
+          <a:prstGeom prst="roundRect">
+            <a:avLst>
+              <a:gd name="adj" fmla="val 12500"/>
+            </a:avLst>
+          </a:prstGeom>
+          <a:solidFill>
+            <a:srgbClr val="7A5C9E"/>
+          </a:solidFill>
+          <a:ln/>
+        </p:spPr>
+      </p:sp>
+      <p:sp>
+        <p:nvSpPr>
+          <p:cNvPr id="23" name="Text 21"/>
+          <p:cNvSpPr/>
+          <p:nvPr/>
+        </p:nvSpPr>
+        <p:spPr>
+          <a:xfrm>
+            <a:off x="9742018" y="2377440"/>
+            <a:ext cx="1578254" cy="685800"/>
+          </a:xfrm>
+          <a:prstGeom prst="rect">
+            <a:avLst/>
+          </a:prstGeom>
+          <a:noFill/>
+          <a:ln/>
+        </p:spPr>
+        <p:txBody>
+          <a:bodyPr wrap="square" rtlCol="0" anchor="ctr"/>
+          <a:lstStyle/>
+          <a:p>
+            <a:pPr indent="0" marL="0">
+              <a:lnSpc>
+                <a:spcPct val="95000"/>
+              </a:lnSpc>
+              <a:buNone/>
+            </a:pPr>
+            <a:r>
+              <a:rPr lang="en-US" sz="1550" b="1" dirty="0">
+                <a:solidFill>
+                  <a:srgbClr val="7A5C9E"/>
+                </a:solidFill>
+                <a:latin typeface="Calibri" pitchFamily="34" charset="0"/>
+                <a:ea typeface="Calibri" pitchFamily="34" charset="-122"/>
+                <a:cs typeface="Calibri" pitchFamily="34" charset="-120"/>
+              </a:rPr>
+              <a:t>Outposts &amp; Wavelength</a:t>
+            </a:r>
+            <a:endParaRPr lang="en-US" sz="1550" dirty="0"/>
+          </a:p>
+        </p:txBody>
+      </p:sp>
+      <p:sp>
+        <p:nvSpPr>
+          <p:cNvPr id="24" name="Text 22"/>
+          <p:cNvSpPr/>
+          <p:nvPr/>
+        </p:nvSpPr>
+        <p:spPr>
+          <a:xfrm>
+            <a:off x="9742018" y="3154680"/>
+            <a:ext cx="1578254" cy="1371600"/>
+          </a:xfrm>
+          <a:prstGeom prst="rect">
+            <a:avLst/>
+          </a:prstGeom>
+          <a:noFill/>
+          <a:ln/>
+        </p:spPr>
+        <p:txBody>
+          <a:bodyPr wrap="square" rtlCol="0" anchor="ctr"/>
+          <a:lstStyle/>
+          <a:p>
+            <a:pPr indent="0" marL="0">
+              <a:lnSpc>
+                <a:spcPct val="105000"/>
+              </a:lnSpc>
+              <a:buNone/>
+            </a:pPr>
+            <a:r>
+              <a:rPr lang="en-US" sz="1250" dirty="0">
+                <a:solidFill>
+                  <a:srgbClr val="5B6570"/>
+                </a:solidFill>
+                <a:latin typeface="Calibri" pitchFamily="34" charset="0"/>
+                <a:ea typeface="Calibri" pitchFamily="34" charset="-122"/>
+                <a:cs typeface="Calibri" pitchFamily="34" charset="-120"/>
+              </a:rPr>
+              <a:t>Deployed on-site or embedded in telecom networks — count depends on customer demand, not a fixed footprint.</a:t>
+            </a:r>
+            <a:endParaRPr lang="en-US" sz="1250" dirty="0"/>
+          </a:p>
+        </p:txBody>
+      </p:sp>
+      <p:sp>
+        <p:nvSpPr>
+          <p:cNvPr id="25" name="Shape 23"/>
+          <p:cNvSpPr/>
+          <p:nvPr/>
+        </p:nvSpPr>
+        <p:spPr>
+          <a:xfrm>
+            <a:off x="640080" y="5074920"/>
+            <a:ext cx="10908792" cy="868680"/>
+          </a:xfrm>
+          <a:prstGeom prst="roundRect">
+            <a:avLst>
+              <a:gd name="adj" fmla="val 10526"/>
+            </a:avLst>
+          </a:prstGeom>
+          <a:solidFill>
+            <a:srgbClr val="232F3E"/>
+          </a:solidFill>
+          <a:ln/>
+        </p:spPr>
+      </p:sp>
+      <p:sp>
+        <p:nvSpPr>
+          <p:cNvPr id="26" name="Text 24"/>
+          <p:cNvSpPr/>
+          <p:nvPr/>
+        </p:nvSpPr>
+        <p:spPr>
+          <a:xfrm>
+            <a:off x="1051560" y="5257800"/>
+            <a:ext cx="10085832" cy="548640"/>
+          </a:xfrm>
+          <a:prstGeom prst="rect">
+            <a:avLst/>
+          </a:prstGeom>
+          <a:noFill/>
+          <a:ln/>
+        </p:spPr>
+        <p:txBody>
+          <a:bodyPr wrap="square" rtlCol="0" anchor="ctr"/>
+          <a:lstStyle/>
+          <a:p>
+            <a:pPr indent="0" marL="0">
+              <a:buNone/>
+            </a:pPr>
+            <a:r>
+              <a:rPr lang="en-US" sz="1500" dirty="0">
+                <a:solidFill>
+                  <a:srgbClr val="D6DEE7"/>
+                </a:solidFill>
+                <a:latin typeface="Calibri" pitchFamily="34" charset="0"/>
+                <a:ea typeface="Calibri" pitchFamily="34" charset="-122"/>
+                <a:cs typeface="Calibri" pitchFamily="34" charset="-120"/>
+              </a:rPr>
+              <a:t>Verify before you quote a number:  </a:t>
+            </a:r>
+            <a:pPr indent="0" marL="0">
+              <a:buNone/>
+            </a:pPr>
+            <a:r>
+              <a:rPr lang="en-US" sz="1500" b="1" dirty="0">
+                <a:solidFill>
+                  <a:srgbClr val="FF9900"/>
+                </a:solidFill>
+                <a:latin typeface="Calibri" pitchFamily="34" charset="0"/>
+                <a:ea typeface="Calibri" pitchFamily="34" charset="-122"/>
+                <a:cs typeface="Calibri" pitchFamily="34" charset="-120"/>
+              </a:rPr>
+              <a:t>AWS adds Regions, AZs, and Local Zones regularly — check aws.amazon.com/about-aws/global-infrastructure for the current count rather than memorizing today’s.</a:t>
+            </a:r>
+            <a:endParaRPr lang="en-US" sz="1500" dirty="0"/>
+          </a:p>
+        </p:txBody>
+      </p:sp>
+      <p:sp>
+        <p:nvSpPr>
+          <p:cNvPr id="27" name="Text 25"/>
+          <p:cNvSpPr/>
+          <p:nvPr/>
+        </p:nvSpPr>
+        <p:spPr>
+          <a:xfrm>
+            <a:off x="640080" y="6473952"/>
+            <a:ext cx="5943600" cy="274320"/>
+          </a:xfrm>
+          <a:prstGeom prst="rect">
+            <a:avLst/>
+          </a:prstGeom>
+          <a:noFill/>
+          <a:ln/>
+        </p:spPr>
+        <p:txBody>
+          <a:bodyPr wrap="square" rtlCol="0" anchor="ctr"/>
+          <a:lstStyle/>
+          <a:p>
+            <a:pPr indent="0" marL="0">
+              <a:buNone/>
+            </a:pPr>
+            <a:r>
+              <a:rPr lang="en-US" sz="900" dirty="0">
+                <a:solidFill>
+                  <a:srgbClr val="5B6570"/>
+                </a:solidFill>
+                <a:latin typeface="Calibri" pitchFamily="34" charset="0"/>
+                <a:ea typeface="Calibri" pitchFamily="34" charset="-122"/>
+                <a:cs typeface="Calibri" pitchFamily="34" charset="-120"/>
+              </a:rPr>
+              <a:t>AWS SAA-A  ·  Lecture 3  ·  AWS Global Infrastructure Overview</a:t>
+            </a:r>
+            <a:endParaRPr lang="en-US" sz="900" dirty="0"/>
+          </a:p>
+        </p:txBody>
+      </p:sp>
+      <p:sp>
+        <p:nvSpPr>
+          <p:cNvPr id="28" name="Text 26"/>
+          <p:cNvSpPr/>
+          <p:nvPr/>
+        </p:nvSpPr>
+        <p:spPr>
+          <a:xfrm>
+            <a:off x="11000232" y="6473952"/>
+            <a:ext cx="548640" cy="274320"/>
+          </a:xfrm>
+          <a:prstGeom prst="rect">
+            <a:avLst/>
+          </a:prstGeom>
+          <a:noFill/>
+          <a:ln/>
+        </p:spPr>
+        <p:txBody>
+          <a:bodyPr wrap="square" rtlCol="0" anchor="ctr"/>
+          <a:lstStyle/>
+          <a:p>
+            <a:pPr algn="r" indent="0" marL="0">
+              <a:buNone/>
+            </a:pPr>
+            <a:r>
+              <a:rPr lang="en-US" sz="900" dirty="0">
+                <a:solidFill>
+                  <a:srgbClr val="5B6570"/>
+                </a:solidFill>
+                <a:latin typeface="Calibri" pitchFamily="34" charset="0"/>
+                <a:ea typeface="Calibri" pitchFamily="34" charset="-122"/>
+                <a:cs typeface="Calibri" pitchFamily="34" charset="-120"/>
+              </a:rPr>
+              <a:t>11</a:t>
+            </a:r>
+            <a:endParaRPr lang="en-US" sz="900" dirty="0"/>
+          </a:p>
+        </p:txBody>
+      </p:sp>
+    </p:spTree>
+  </p:cSld>
+  <p:clrMapOvr>
+    <a:masterClrMapping/>
+  </p:clrMapOvr>
+</p:sld>
+</file>
+
+<file path=ppt/slides/slide35.xml><?xml version="1.0" encoding="utf-8"?>
+<p:sld xmlns:a="http://schemas.openxmlformats.org/drawingml/2006/main" xmlns:r="http://schemas.openxmlformats.org/officeDocument/2006/relationships" xmlns:p="http://schemas.openxmlformats.org/presentationml/2006/main">
+  <p:cSld name="Slide 16">
+    <p:bg>
+      <p:bgPr>
+        <a:solidFill>
+          <a:srgbClr val="F4F6F8"/>
+        </a:solidFill>
+      </p:bgPr>
+    </p:bg>
+    <p:spTree>
+      <p:nvGrpSpPr>
+        <p:cNvPr id="1" name=""/>
+        <p:cNvGrpSpPr/>
+        <p:nvPr/>
+      </p:nvGrpSpPr>
+      <p:grpSpPr>
+        <a:xfrm>
+          <a:off x="0" y="0"/>
+          <a:ext cx="0" cy="0"/>
+          <a:chOff x="0" y="0"/>
+          <a:chExt cx="0" cy="0"/>
+        </a:xfrm>
+      </p:grpSpPr>
+      <p:sp>
+        <p:nvSpPr>
+          <p:cNvPr id="2" name="Text 0"/>
+          <p:cNvSpPr/>
+          <p:nvPr/>
+        </p:nvSpPr>
+        <p:spPr>
+          <a:xfrm>
+            <a:off x="640080" y="457200"/>
+            <a:ext cx="10908792" cy="274320"/>
+          </a:xfrm>
+          <a:prstGeom prst="rect">
+            <a:avLst/>
+          </a:prstGeom>
+          <a:noFill/>
+          <a:ln/>
+        </p:spPr>
+        <p:txBody>
+          <a:bodyPr wrap="square" rtlCol="0" anchor="ctr"/>
+          <a:lstStyle/>
+          <a:p>
+            <a:pPr indent="0" marL="0">
+              <a:buNone/>
+            </a:pPr>
+            <a:r>
+              <a:rPr lang="en-US" sz="1200" b="1" spc="200" kern="0" dirty="0">
+                <a:solidFill>
+                  <a:srgbClr val="EC7211"/>
+                </a:solidFill>
+                <a:latin typeface="Calibri" pitchFamily="34" charset="0"/>
+                <a:ea typeface="Calibri" pitchFamily="34" charset="-122"/>
+                <a:cs typeface="Calibri" pitchFamily="34" charset="-120"/>
+              </a:rPr>
+              <a:t>A BIGGER ARCHITECTURE DECISION</a:t>
+            </a:r>
+            <a:endParaRPr lang="en-US" sz="1200" dirty="0"/>
+          </a:p>
+        </p:txBody>
+      </p:sp>
+      <p:sp>
+        <p:nvSpPr>
+          <p:cNvPr id="3" name="Text 1"/>
+          <p:cNvSpPr/>
+          <p:nvPr/>
+        </p:nvSpPr>
+        <p:spPr>
+          <a:xfrm>
+            <a:off x="640080" y="731520"/>
+            <a:ext cx="10908792" cy="640080"/>
+          </a:xfrm>
+          <a:prstGeom prst="rect">
+            <a:avLst/>
+          </a:prstGeom>
+          <a:noFill/>
+          <a:ln/>
+        </p:spPr>
+        <p:txBody>
+          <a:bodyPr wrap="square" rtlCol="0" anchor="ctr"/>
+          <a:lstStyle/>
+          <a:p>
+            <a:pPr indent="0" marL="0">
+              <a:buNone/>
+            </a:pPr>
+            <a:r>
+              <a:rPr lang="en-US" sz="3200" b="1" dirty="0">
+                <a:solidFill>
+                  <a:srgbClr val="232F3E"/>
+                </a:solidFill>
+                <a:latin typeface="Calibri" pitchFamily="34" charset="0"/>
+                <a:ea typeface="Calibri" pitchFamily="34" charset="-122"/>
+                <a:cs typeface="Calibri" pitchFamily="34" charset="-120"/>
+              </a:rPr>
+              <a:t>Single-Region vs. Multi-Region Design</a:t>
+            </a:r>
+            <a:endParaRPr lang="en-US" sz="3200" dirty="0"/>
+          </a:p>
+        </p:txBody>
+      </p:sp>
+      <p:sp>
+        <p:nvSpPr>
+          <p:cNvPr id="4" name="Text 2"/>
+          <p:cNvSpPr/>
+          <p:nvPr/>
+        </p:nvSpPr>
+        <p:spPr>
+          <a:xfrm>
+            <a:off x="640080" y="1417320"/>
+            <a:ext cx="10908792" cy="365760"/>
+          </a:xfrm>
+          <a:prstGeom prst="rect">
+            <a:avLst/>
+          </a:prstGeom>
+          <a:noFill/>
+          <a:ln/>
+        </p:spPr>
+        <p:txBody>
+          <a:bodyPr wrap="square" rtlCol="0" anchor="ctr"/>
+          <a:lstStyle/>
+          <a:p>
+            <a:pPr indent="0" marL="0">
+              <a:buNone/>
+            </a:pPr>
+            <a:r>
+              <a:rPr lang="en-US" sz="1500" i="1" dirty="0">
+                <a:solidFill>
+                  <a:srgbClr val="5B6570"/>
+                </a:solidFill>
+                <a:latin typeface="Calibri" pitchFamily="34" charset="0"/>
+                <a:ea typeface="Calibri" pitchFamily="34" charset="-122"/>
+                <a:cs typeface="Calibri" pitchFamily="34" charset="-120"/>
+              </a:rPr>
+              <a:t>Multi-AZ protects against a data center problem. It doesn’t protect against a whole Region having a bad day.</a:t>
+            </a:r>
+            <a:endParaRPr lang="en-US" sz="1500" dirty="0"/>
+          </a:p>
+        </p:txBody>
+      </p:sp>
+      <p:sp>
+        <p:nvSpPr>
+          <p:cNvPr id="5" name="Shape 3"/>
+          <p:cNvSpPr/>
+          <p:nvPr/>
+        </p:nvSpPr>
+        <p:spPr>
+          <a:xfrm>
+            <a:off x="640080" y="1965960"/>
+            <a:ext cx="5257800" cy="3291840"/>
+          </a:xfrm>
+          <a:prstGeom prst="roundRect">
+            <a:avLst>
+              <a:gd name="adj" fmla="val 3333"/>
+            </a:avLst>
+          </a:prstGeom>
+          <a:solidFill>
+            <a:srgbClr val="FFFFFF"/>
+          </a:solidFill>
+          <a:ln w="12700">
+            <a:solidFill>
+              <a:srgbClr val="DCE1E6"/>
+            </a:solidFill>
+            <a:prstDash val="solid"/>
+          </a:ln>
+        </p:spPr>
+      </p:sp>
+      <p:sp>
+        <p:nvSpPr>
+          <p:cNvPr id="6" name="Text 4"/>
+          <p:cNvSpPr/>
+          <p:nvPr/>
+        </p:nvSpPr>
+        <p:spPr>
+          <a:xfrm>
+            <a:off x="1005840" y="2194560"/>
+            <a:ext cx="4572000" cy="320040"/>
+          </a:xfrm>
+          <a:prstGeom prst="rect">
+            <a:avLst/>
+          </a:prstGeom>
+          <a:noFill/>
+          <a:ln/>
+        </p:spPr>
+        <p:txBody>
+          <a:bodyPr wrap="square" rtlCol="0" anchor="ctr"/>
+          <a:lstStyle/>
+          <a:p>
+            <a:pPr indent="0" marL="0">
+              <a:buNone/>
+            </a:pPr>
+            <a:r>
+              <a:rPr lang="en-US" sz="1200" b="1" spc="200" kern="0" dirty="0">
+                <a:solidFill>
+                  <a:srgbClr val="C0392B"/>
+                </a:solidFill>
+                <a:latin typeface="Calibri" pitchFamily="34" charset="0"/>
+                <a:ea typeface="Calibri" pitchFamily="34" charset="-122"/>
+                <a:cs typeface="Calibri" pitchFamily="34" charset="-120"/>
+              </a:rPr>
+              <a:t>SINGLE-REGION</a:t>
+            </a:r>
+            <a:endParaRPr lang="en-US" sz="1200" dirty="0"/>
+          </a:p>
+        </p:txBody>
+      </p:sp>
+      <p:sp>
+        <p:nvSpPr>
+          <p:cNvPr id="7" name="Text 5"/>
+          <p:cNvSpPr/>
+          <p:nvPr/>
+        </p:nvSpPr>
+        <p:spPr>
+          <a:xfrm>
+            <a:off x="1005840" y="2697480"/>
+            <a:ext cx="4572000" cy="1463040"/>
+          </a:xfrm>
+          <a:prstGeom prst="rect">
+            <a:avLst/>
+          </a:prstGeom>
+          <a:noFill/>
+          <a:ln/>
+        </p:spPr>
+        <p:txBody>
+          <a:bodyPr wrap="square" rtlCol="0" anchor="ctr"/>
+          <a:lstStyle/>
+          <a:p>
+            <a:pPr indent="0" marL="0">
+              <a:lnSpc>
+                <a:spcPct val="135000"/>
+              </a:lnSpc>
+              <a:buNone/>
+            </a:pPr>
+            <a:r>
+              <a:rPr lang="en-US" sz="1700" dirty="0">
+                <a:solidFill>
+                  <a:srgbClr val="5B6570"/>
+                </a:solidFill>
+                <a:latin typeface="Calibri" pitchFamily="34" charset="0"/>
+                <a:ea typeface="Calibri" pitchFamily="34" charset="-122"/>
+                <a:cs typeface="Calibri" pitchFamily="34" charset="-120"/>
+              </a:rPr>
+              <a:t>us-east-1: App + DB, spread across 3 AZs</a:t>
+            </a:r>
+            <a:endParaRPr lang="en-US" sz="1700" dirty="0"/>
+          </a:p>
+          <a:p>
+            <a:pPr indent="0" marL="0">
+              <a:lnSpc>
+                <a:spcPct val="135000"/>
+              </a:lnSpc>
+              <a:buNone/>
+            </a:pPr>
+            <a:r>
+              <a:rPr lang="en-US" sz="1700" dirty="0">
+                <a:solidFill>
+                  <a:srgbClr val="5B6570"/>
+                </a:solidFill>
+                <a:latin typeface="Calibri" pitchFamily="34" charset="0"/>
+                <a:ea typeface="Calibri" pitchFamily="34" charset="-122"/>
+                <a:cs typeface="Calibri" pitchFamily="34" charset="-120"/>
+              </a:rPr>
+              <a:t>One Region, one blast radius</a:t>
+            </a:r>
+            <a:endParaRPr lang="en-US" sz="1700" dirty="0"/>
+          </a:p>
+          <a:p>
+            <a:pPr indent="0" marL="0">
+              <a:lnSpc>
+                <a:spcPct val="135000"/>
+              </a:lnSpc>
+              <a:buNone/>
+            </a:pPr>
+            <a:r>
+              <a:rPr lang="en-US" sz="1700" dirty="0">
+                <a:solidFill>
+                  <a:srgbClr val="5B6570"/>
+                </a:solidFill>
+                <a:latin typeface="Calibri" pitchFamily="34" charset="0"/>
+                <a:ea typeface="Calibri" pitchFamily="34" charset="-122"/>
+                <a:cs typeface="Calibri" pitchFamily="34" charset="-120"/>
+              </a:rPr>
+              <a:t>Simpler to build, cheaper to run</a:t>
+            </a:r>
+            <a:endParaRPr lang="en-US" sz="1700" dirty="0"/>
+          </a:p>
+        </p:txBody>
+      </p:sp>
+      <p:sp>
+        <p:nvSpPr>
+          <p:cNvPr id="8" name="Text 6"/>
+          <p:cNvSpPr/>
+          <p:nvPr/>
+        </p:nvSpPr>
+        <p:spPr>
+          <a:xfrm>
+            <a:off x="1005840" y="4389120"/>
+            <a:ext cx="4572000" cy="548640"/>
+          </a:xfrm>
+          <a:prstGeom prst="rect">
+            <a:avLst/>
+          </a:prstGeom>
+          <a:noFill/>
+          <a:ln/>
+        </p:spPr>
+        <p:txBody>
+          <a:bodyPr wrap="square" rtlCol="0" anchor="ctr"/>
+          <a:lstStyle/>
+          <a:p>
+            <a:pPr indent="0" marL="0">
+              <a:buNone/>
+            </a:pPr>
+            <a:r>
+              <a:rPr lang="en-US" sz="1400" i="1" dirty="0">
+                <a:solidFill>
+                  <a:srgbClr val="C0392B"/>
+                </a:solidFill>
+                <a:latin typeface="Calibri" pitchFamily="34" charset="0"/>
+                <a:ea typeface="Calibri" pitchFamily="34" charset="-122"/>
+                <a:cs typeface="Calibri" pitchFamily="34" charset="-120"/>
+              </a:rPr>
+              <a:t>“What if the whole Region has a problem?”</a:t>
+            </a:r>
+            <a:endParaRPr lang="en-US" sz="1400" dirty="0"/>
+          </a:p>
+        </p:txBody>
+      </p:sp>
+      <p:sp>
+        <p:nvSpPr>
+          <p:cNvPr id="9" name="Shape 7"/>
+          <p:cNvSpPr/>
+          <p:nvPr/>
+        </p:nvSpPr>
+        <p:spPr>
+          <a:xfrm>
+            <a:off x="6263640" y="1965960"/>
+            <a:ext cx="5257800" cy="3291840"/>
+          </a:xfrm>
+          <a:prstGeom prst="roundRect">
+            <a:avLst>
+              <a:gd name="adj" fmla="val 3333"/>
+            </a:avLst>
+          </a:prstGeom>
+          <a:solidFill>
+            <a:srgbClr val="232F3E"/>
+          </a:solidFill>
+          <a:ln/>
+        </p:spPr>
+      </p:sp>
+      <p:sp>
+        <p:nvSpPr>
+          <p:cNvPr id="10" name="Text 8"/>
+          <p:cNvSpPr/>
+          <p:nvPr/>
+        </p:nvSpPr>
+        <p:spPr>
+          <a:xfrm>
+            <a:off x="6629400" y="2194560"/>
+            <a:ext cx="4572000" cy="320040"/>
+          </a:xfrm>
+          <a:prstGeom prst="rect">
+            <a:avLst/>
+          </a:prstGeom>
+          <a:noFill/>
+          <a:ln/>
+        </p:spPr>
+        <p:txBody>
+          <a:bodyPr wrap="square" rtlCol="0" anchor="ctr"/>
+          <a:lstStyle/>
+          <a:p>
+            <a:pPr indent="0" marL="0">
+              <a:buNone/>
+            </a:pPr>
+            <a:r>
+              <a:rPr lang="en-US" sz="1200" b="1" spc="200" kern="0" dirty="0">
+                <a:solidFill>
+                  <a:srgbClr val="5FD08A"/>
+                </a:solidFill>
+                <a:latin typeface="Calibri" pitchFamily="34" charset="0"/>
+                <a:ea typeface="Calibri" pitchFamily="34" charset="-122"/>
+                <a:cs typeface="Calibri" pitchFamily="34" charset="-120"/>
+              </a:rPr>
+              <a:t>MULTI-REGION</a:t>
+            </a:r>
+            <a:endParaRPr lang="en-US" sz="1200" dirty="0"/>
+          </a:p>
+        </p:txBody>
+      </p:sp>
+      <p:sp>
+        <p:nvSpPr>
+          <p:cNvPr id="11" name="Text 9"/>
+          <p:cNvSpPr/>
+          <p:nvPr/>
+        </p:nvSpPr>
+        <p:spPr>
+          <a:xfrm>
+            <a:off x="6629400" y="2697480"/>
+            <a:ext cx="4572000" cy="1463040"/>
+          </a:xfrm>
+          <a:prstGeom prst="rect">
+            <a:avLst/>
+          </a:prstGeom>
+          <a:noFill/>
+          <a:ln/>
+        </p:spPr>
+        <p:txBody>
+          <a:bodyPr wrap="square" rtlCol="0" anchor="ctr"/>
+          <a:lstStyle/>
+          <a:p>
+            <a:pPr indent="0" marL="0">
+              <a:lnSpc>
+                <a:spcPct val="135000"/>
+              </a:lnSpc>
+              <a:buNone/>
+            </a:pPr>
+            <a:r>
+              <a:rPr lang="en-US" sz="1600" dirty="0">
+                <a:solidFill>
+                  <a:srgbClr val="D6DEE7"/>
+                </a:solidFill>
+                <a:latin typeface="Calibri" pitchFamily="34" charset="0"/>
+                <a:ea typeface="Calibri" pitchFamily="34" charset="-122"/>
+                <a:cs typeface="Calibri" pitchFamily="34" charset="-120"/>
+              </a:rPr>
+              <a:t>us-east-1 primary, us-west-2 standby</a:t>
+            </a:r>
+            <a:endParaRPr lang="en-US" sz="1600" dirty="0"/>
+          </a:p>
+          <a:p>
+            <a:pPr indent="0" marL="0">
+              <a:lnSpc>
+                <a:spcPct val="135000"/>
+              </a:lnSpc>
+              <a:buNone/>
+            </a:pPr>
+            <a:r>
+              <a:rPr lang="en-US" sz="1600" dirty="0">
+                <a:solidFill>
+                  <a:srgbClr val="D6DEE7"/>
+                </a:solidFill>
+                <a:latin typeface="Calibri" pitchFamily="34" charset="0"/>
+                <a:ea typeface="Calibri" pitchFamily="34" charset="-122"/>
+                <a:cs typeface="Calibri" pitchFamily="34" charset="-120"/>
+              </a:rPr>
+              <a:t>Data replicated across Regions</a:t>
+            </a:r>
+            <a:endParaRPr lang="en-US" sz="1600" dirty="0"/>
+          </a:p>
+          <a:p>
+            <a:pPr indent="0" marL="0">
+              <a:lnSpc>
+                <a:spcPct val="135000"/>
+              </a:lnSpc>
+              <a:buNone/>
+            </a:pPr>
+            <a:r>
+              <a:rPr lang="en-US" sz="1600" dirty="0">
+                <a:solidFill>
+                  <a:srgbClr val="D6DEE7"/>
+                </a:solidFill>
+                <a:latin typeface="Calibri" pitchFamily="34" charset="0"/>
+                <a:ea typeface="Calibri" pitchFamily="34" charset="-122"/>
+                <a:cs typeface="Calibri" pitchFamily="34" charset="-120"/>
+              </a:rPr>
+              <a:t>Failover ready if the primary Region has a problem</a:t>
+            </a:r>
+            <a:endParaRPr lang="en-US" sz="1600" dirty="0"/>
+          </a:p>
+        </p:txBody>
+      </p:sp>
+      <p:sp>
+        <p:nvSpPr>
+          <p:cNvPr id="12" name="Text 10"/>
+          <p:cNvSpPr/>
+          <p:nvPr/>
+        </p:nvSpPr>
+        <p:spPr>
+          <a:xfrm>
+            <a:off x="6629400" y="4389120"/>
+            <a:ext cx="4572000" cy="548640"/>
+          </a:xfrm>
+          <a:prstGeom prst="rect">
+            <a:avLst/>
+          </a:prstGeom>
+          <a:noFill/>
+          <a:ln/>
+        </p:spPr>
+        <p:txBody>
+          <a:bodyPr wrap="square" rtlCol="0" anchor="ctr"/>
+          <a:lstStyle/>
+          <a:p>
+            <a:pPr indent="0" marL="0">
+              <a:buNone/>
+            </a:pPr>
+            <a:r>
+              <a:rPr lang="en-US" sz="1400" i="1" dirty="0">
+                <a:solidFill>
+                  <a:srgbClr val="5FD08A"/>
+                </a:solidFill>
+                <a:latin typeface="Calibri" pitchFamily="34" charset="0"/>
+                <a:ea typeface="Calibri" pitchFamily="34" charset="-122"/>
+                <a:cs typeface="Calibri" pitchFamily="34" charset="-120"/>
+              </a:rPr>
+              <a:t>“Rare, expensive, and usually reserved for workloads that truly can’t go down.”</a:t>
+            </a:r>
+            <a:endParaRPr lang="en-US" sz="1400" dirty="0"/>
+          </a:p>
+        </p:txBody>
+      </p:sp>
+      <p:sp>
+        <p:nvSpPr>
+          <p:cNvPr id="13" name="Text 11"/>
+          <p:cNvSpPr/>
+          <p:nvPr/>
+        </p:nvSpPr>
+        <p:spPr>
+          <a:xfrm>
+            <a:off x="640080" y="5532120"/>
+            <a:ext cx="10908792" cy="365760"/>
+          </a:xfrm>
+          <a:prstGeom prst="rect">
+            <a:avLst/>
+          </a:prstGeom>
+          <a:noFill/>
+          <a:ln/>
+        </p:spPr>
+        <p:txBody>
+          <a:bodyPr wrap="square" rtlCol="0" anchor="ctr"/>
+          <a:lstStyle/>
+          <a:p>
+            <a:pPr algn="ctr" indent="0" marL="0">
+              <a:buNone/>
+            </a:pPr>
+            <a:r>
+              <a:rPr lang="en-US" sz="1400" i="1" dirty="0">
+                <a:solidFill>
+                  <a:srgbClr val="5B6570"/>
+                </a:solidFill>
+                <a:latin typeface="Calibri" pitchFamily="34" charset="0"/>
+                <a:ea typeface="Calibri" pitchFamily="34" charset="-122"/>
+                <a:cs typeface="Calibri" pitchFamily="34" charset="-120"/>
+              </a:rPr>
+              <a:t>Multi-Region is a real design choice, not a default — most workloads are well served by solid multi-AZ alone.</a:t>
+            </a:r>
+            <a:endParaRPr lang="en-US" sz="1400" dirty="0"/>
+          </a:p>
+        </p:txBody>
+      </p:sp>
+      <p:sp>
+        <p:nvSpPr>
+          <p:cNvPr id="14" name="Text 12"/>
+          <p:cNvSpPr/>
+          <p:nvPr/>
+        </p:nvSpPr>
+        <p:spPr>
+          <a:xfrm>
+            <a:off x="640080" y="6473952"/>
+            <a:ext cx="5943600" cy="274320"/>
+          </a:xfrm>
+          <a:prstGeom prst="rect">
+            <a:avLst/>
+          </a:prstGeom>
+          <a:noFill/>
+          <a:ln/>
+        </p:spPr>
+        <p:txBody>
+          <a:bodyPr wrap="square" rtlCol="0" anchor="ctr"/>
+          <a:lstStyle/>
+          <a:p>
+            <a:pPr indent="0" marL="0">
+              <a:buNone/>
+            </a:pPr>
+            <a:r>
+              <a:rPr lang="en-US" sz="900" dirty="0">
+                <a:solidFill>
+                  <a:srgbClr val="5B6570"/>
+                </a:solidFill>
+                <a:latin typeface="Calibri" pitchFamily="34" charset="0"/>
+                <a:ea typeface="Calibri" pitchFamily="34" charset="-122"/>
+                <a:cs typeface="Calibri" pitchFamily="34" charset="-120"/>
+              </a:rPr>
+              <a:t>AWS SAA-A  ·  Lecture 3  ·  AWS Global Infrastructure Overview</a:t>
+            </a:r>
+            <a:endParaRPr lang="en-US" sz="900" dirty="0"/>
+          </a:p>
+        </p:txBody>
+      </p:sp>
+      <p:sp>
+        <p:nvSpPr>
+          <p:cNvPr id="15" name="Text 13"/>
+          <p:cNvSpPr/>
+          <p:nvPr/>
+        </p:nvSpPr>
+        <p:spPr>
+          <a:xfrm>
+            <a:off x="11000232" y="6473952"/>
+            <a:ext cx="548640" cy="274320"/>
+          </a:xfrm>
+          <a:prstGeom prst="rect">
+            <a:avLst/>
+          </a:prstGeom>
+          <a:noFill/>
+          <a:ln/>
+        </p:spPr>
+        <p:txBody>
+          <a:bodyPr wrap="square" rtlCol="0" anchor="ctr"/>
+          <a:lstStyle/>
+          <a:p>
+            <a:pPr algn="r" indent="0" marL="0">
+              <a:buNone/>
+            </a:pPr>
+            <a:r>
+              <a:rPr lang="en-US" sz="900" dirty="0">
+                <a:solidFill>
+                  <a:srgbClr val="5B6570"/>
+                </a:solidFill>
+                <a:latin typeface="Calibri" pitchFamily="34" charset="0"/>
+                <a:ea typeface="Calibri" pitchFamily="34" charset="-122"/>
+                <a:cs typeface="Calibri" pitchFamily="34" charset="-120"/>
+              </a:rPr>
+              <a:t>12</a:t>
+            </a:r>
+            <a:endParaRPr lang="en-US" sz="900" dirty="0"/>
+          </a:p>
+        </p:txBody>
+      </p:sp>
+    </p:spTree>
+  </p:cSld>
+  <p:clrMapOvr>
+    <a:masterClrMapping/>
+  </p:clrMapOvr>
+</p:sld>
+</file>
+
+<file path=ppt/slides/slide36.xml><?xml version="1.0" encoding="utf-8"?>
+<p:sld xmlns:a="http://schemas.openxmlformats.org/drawingml/2006/main" xmlns:r="http://schemas.openxmlformats.org/officeDocument/2006/relationships" xmlns:p="http://schemas.openxmlformats.org/presentationml/2006/main">
+  <p:cSld name="Slide 15">
+    <p:bg>
+      <p:bgPr>
+        <a:solidFill>
+          <a:srgbClr val="F4F6F8"/>
+        </a:solidFill>
+      </p:bgPr>
+    </p:bg>
+    <p:spTree>
+      <p:nvGrpSpPr>
+        <p:cNvPr id="1" name=""/>
+        <p:cNvGrpSpPr/>
+        <p:nvPr/>
+      </p:nvGrpSpPr>
+      <p:grpSpPr>
+        <a:xfrm>
+          <a:off x="0" y="0"/>
+          <a:ext cx="0" cy="0"/>
+          <a:chOff x="0" y="0"/>
+          <a:chExt cx="0" cy="0"/>
+        </a:xfrm>
+      </p:grpSpPr>
+      <p:sp>
+        <p:nvSpPr>
+          <p:cNvPr id="2" name="Text 0"/>
+          <p:cNvSpPr/>
+          <p:nvPr/>
+        </p:nvSpPr>
+        <p:spPr>
+          <a:xfrm>
+            <a:off x="640080" y="457200"/>
+            <a:ext cx="10908792" cy="274320"/>
+          </a:xfrm>
+          <a:prstGeom prst="rect">
+            <a:avLst/>
+          </a:prstGeom>
+          <a:noFill/>
+          <a:ln/>
+        </p:spPr>
+        <p:txBody>
+          <a:bodyPr wrap="square" rtlCol="0" anchor="ctr"/>
+          <a:lstStyle/>
+          <a:p>
+            <a:pPr indent="0" marL="0">
+              <a:buNone/>
+            </a:pPr>
+            <a:r>
+              <a:rPr lang="en-US" sz="1200" b="1" spc="200" kern="0" dirty="0">
+                <a:solidFill>
+                  <a:srgbClr val="EC7211"/>
+                </a:solidFill>
+                <a:latin typeface="Calibri" pitchFamily="34" charset="0"/>
+                <a:ea typeface="Calibri" pitchFamily="34" charset="-122"/>
+                <a:cs typeface="Calibri" pitchFamily="34" charset="-120"/>
+              </a:rPr>
+              <a:t>PUTTING IT TOGETHER</a:t>
+            </a:r>
+            <a:endParaRPr lang="en-US" sz="1200" dirty="0"/>
+          </a:p>
+        </p:txBody>
+      </p:sp>
+      <p:sp>
+        <p:nvSpPr>
+          <p:cNvPr id="3" name="Text 1"/>
+          <p:cNvSpPr/>
+          <p:nvPr/>
+        </p:nvSpPr>
+        <p:spPr>
+          <a:xfrm>
+            <a:off x="640080" y="731520"/>
+            <a:ext cx="10908792" cy="640080"/>
+          </a:xfrm>
+          <a:prstGeom prst="rect">
+            <a:avLst/>
+          </a:prstGeom>
+          <a:noFill/>
+          <a:ln/>
+        </p:spPr>
+        <p:txBody>
+          <a:bodyPr wrap="square" rtlCol="0" anchor="ctr"/>
+          <a:lstStyle/>
+          <a:p>
+            <a:pPr indent="0" marL="0">
+              <a:buNone/>
+            </a:pPr>
+            <a:r>
+              <a:rPr lang="en-US" sz="3200" b="1" dirty="0">
+                <a:solidFill>
+                  <a:srgbClr val="232F3E"/>
+                </a:solidFill>
+                <a:latin typeface="Calibri" pitchFamily="34" charset="0"/>
+                <a:ea typeface="Calibri" pitchFamily="34" charset="-122"/>
+                <a:cs typeface="Calibri" pitchFamily="34" charset="-120"/>
+              </a:rPr>
+              <a:t>Scenario: Where Should This Workload Live?</a:t>
+            </a:r>
+            <a:endParaRPr lang="en-US" sz="3200" dirty="0"/>
+          </a:p>
+        </p:txBody>
+      </p:sp>
+      <p:sp>
+        <p:nvSpPr>
+          <p:cNvPr id="4" name="Text 2"/>
+          <p:cNvSpPr/>
+          <p:nvPr/>
+        </p:nvSpPr>
+        <p:spPr>
+          <a:xfrm>
+            <a:off x="640080" y="1417320"/>
+            <a:ext cx="10908792" cy="365760"/>
+          </a:xfrm>
+          <a:prstGeom prst="rect">
+            <a:avLst/>
+          </a:prstGeom>
+          <a:noFill/>
+          <a:ln/>
+        </p:spPr>
+        <p:txBody>
+          <a:bodyPr wrap="square" rtlCol="0" anchor="ctr"/>
+          <a:lstStyle/>
+          <a:p>
+            <a:pPr indent="0" marL="0">
+              <a:buNone/>
+            </a:pPr>
+            <a:r>
+              <a:rPr lang="en-US" sz="1500" i="1" dirty="0">
+                <a:solidFill>
+                  <a:srgbClr val="5B6570"/>
+                </a:solidFill>
+                <a:latin typeface="Calibri" pitchFamily="34" charset="0"/>
+                <a:ea typeface="Calibri" pitchFamily="34" charset="-122"/>
+                <a:cs typeface="Calibri" pitchFamily="34" charset="-120"/>
+              </a:rPr>
+              <a:t>A German media company wants to launch a video-streaming app for EU customers. Let’s apply tonight’s four factors.</a:t>
+            </a:r>
+            <a:endParaRPr lang="en-US" sz="1500" dirty="0"/>
+          </a:p>
+        </p:txBody>
+      </p:sp>
+      <p:sp>
+        <p:nvSpPr>
+          <p:cNvPr id="5" name="Shape 3"/>
+          <p:cNvSpPr/>
+          <p:nvPr/>
+        </p:nvSpPr>
+        <p:spPr>
+          <a:xfrm>
+            <a:off x="640080" y="1920240"/>
+            <a:ext cx="5394960" cy="3794760"/>
+          </a:xfrm>
+          <a:prstGeom prst="roundRect">
+            <a:avLst>
+              <a:gd name="adj" fmla="val 2892"/>
+            </a:avLst>
+          </a:prstGeom>
+          <a:solidFill>
+            <a:srgbClr val="FFFFFF"/>
+          </a:solidFill>
+          <a:ln w="12700">
+            <a:solidFill>
+              <a:srgbClr val="DCE1E6"/>
+            </a:solidFill>
+            <a:prstDash val="solid"/>
+          </a:ln>
+          <a:effectLst>
+            <a:outerShdw sx="100000" sy="100000" kx="0" ky="0" algn="bl" rotWithShape="0" blurRad="101600" dist="38100" dir="5400000">
+              <a:srgbClr val="C6CDD4">
+                <a:alpha val="50000"/>
+              </a:srgbClr>
+            </a:outerShdw>
+          </a:effectLst>
+        </p:spPr>
+      </p:sp>
+      <p:sp>
+        <p:nvSpPr>
+          <p:cNvPr id="6" name="Text 4"/>
+          <p:cNvSpPr/>
+          <p:nvPr/>
+        </p:nvSpPr>
+        <p:spPr>
+          <a:xfrm>
+            <a:off x="1005840" y="2148840"/>
+            <a:ext cx="4663440" cy="320040"/>
+          </a:xfrm>
+          <a:prstGeom prst="rect">
+            <a:avLst/>
+          </a:prstGeom>
+          <a:noFill/>
+          <a:ln/>
+        </p:spPr>
+        <p:txBody>
+          <a:bodyPr wrap="square" rtlCol="0" anchor="ctr"/>
+          <a:lstStyle/>
+          <a:p>
+            <a:pPr indent="0" marL="0">
+              <a:buNone/>
+            </a:pPr>
+            <a:r>
+              <a:rPr lang="en-US" sz="1200" b="1" spc="200" kern="0" dirty="0">
+                <a:solidFill>
+                  <a:srgbClr val="1E8FA5"/>
+                </a:solidFill>
+                <a:latin typeface="Calibri" pitchFamily="34" charset="0"/>
+                <a:ea typeface="Calibri" pitchFamily="34" charset="-122"/>
+                <a:cs typeface="Calibri" pitchFamily="34" charset="-120"/>
+              </a:rPr>
+              <a:t>THE SCENARIO</a:t>
+            </a:r>
+            <a:endParaRPr lang="en-US" sz="1200" dirty="0"/>
+          </a:p>
+        </p:txBody>
+      </p:sp>
+      <p:sp>
+        <p:nvSpPr>
+          <p:cNvPr id="7" name="Text 5"/>
+          <p:cNvSpPr/>
+          <p:nvPr/>
+        </p:nvSpPr>
+        <p:spPr>
+          <a:xfrm>
+            <a:off x="1005840" y="2606040"/>
+            <a:ext cx="4663440" cy="320040"/>
+          </a:xfrm>
+          <a:prstGeom prst="rect">
+            <a:avLst/>
+          </a:prstGeom>
+          <a:noFill/>
+          <a:ln/>
+        </p:spPr>
+        <p:txBody>
+          <a:bodyPr wrap="square" rtlCol="0" anchor="ctr"/>
+          <a:lstStyle/>
+          <a:p>
+            <a:pPr indent="0" marL="0">
+              <a:buNone/>
+            </a:pPr>
+            <a:r>
+              <a:rPr lang="en-US" sz="1550" b="1" dirty="0">
+                <a:solidFill>
+                  <a:srgbClr val="232F3E"/>
+                </a:solidFill>
+                <a:latin typeface="Calibri" pitchFamily="34" charset="0"/>
+                <a:ea typeface="Calibri" pitchFamily="34" charset="-122"/>
+                <a:cs typeface="Calibri" pitchFamily="34" charset="-120"/>
+              </a:rPr>
+              <a:t>Latency</a:t>
+            </a:r>
+            <a:endParaRPr lang="en-US" sz="1550" dirty="0"/>
+          </a:p>
+        </p:txBody>
+      </p:sp>
+      <p:sp>
+        <p:nvSpPr>
+          <p:cNvPr id="8" name="Text 6"/>
+          <p:cNvSpPr/>
+          <p:nvPr/>
+        </p:nvSpPr>
+        <p:spPr>
+          <a:xfrm>
+            <a:off x="1005840" y="2907792"/>
+            <a:ext cx="4663440" cy="365760"/>
+          </a:xfrm>
+          <a:prstGeom prst="rect">
+            <a:avLst/>
+          </a:prstGeom>
+          <a:noFill/>
+          <a:ln/>
+        </p:spPr>
+        <p:txBody>
+          <a:bodyPr wrap="square" rtlCol="0" anchor="ctr"/>
+          <a:lstStyle/>
+          <a:p>
+            <a:pPr indent="0" marL="0">
+              <a:buNone/>
+            </a:pPr>
+            <a:r>
+              <a:rPr lang="en-US" sz="1300" dirty="0">
+                <a:solidFill>
+                  <a:srgbClr val="5B6570"/>
+                </a:solidFill>
+                <a:latin typeface="Calibri" pitchFamily="34" charset="0"/>
+                <a:ea typeface="Calibri" pitchFamily="34" charset="-122"/>
+                <a:cs typeface="Calibri" pitchFamily="34" charset="-120"/>
+              </a:rPr>
+              <a:t>Viewers are almost entirely in Germany and neighboring countries</a:t>
+            </a:r>
+            <a:endParaRPr lang="en-US" sz="1300" dirty="0"/>
+          </a:p>
+        </p:txBody>
+      </p:sp>
+      <p:sp>
+        <p:nvSpPr>
+          <p:cNvPr id="9" name="Text 7"/>
+          <p:cNvSpPr/>
+          <p:nvPr/>
+        </p:nvSpPr>
+        <p:spPr>
+          <a:xfrm>
+            <a:off x="1005840" y="3383280"/>
+            <a:ext cx="4663440" cy="320040"/>
+          </a:xfrm>
+          <a:prstGeom prst="rect">
+            <a:avLst/>
+          </a:prstGeom>
+          <a:noFill/>
+          <a:ln/>
+        </p:spPr>
+        <p:txBody>
+          <a:bodyPr wrap="square" rtlCol="0" anchor="ctr"/>
+          <a:lstStyle/>
+          <a:p>
+            <a:pPr indent="0" marL="0">
+              <a:buNone/>
+            </a:pPr>
+            <a:r>
+              <a:rPr lang="en-US" sz="1550" b="1" dirty="0">
+                <a:solidFill>
+                  <a:srgbClr val="232F3E"/>
+                </a:solidFill>
+                <a:latin typeface="Calibri" pitchFamily="34" charset="0"/>
+                <a:ea typeface="Calibri" pitchFamily="34" charset="-122"/>
+                <a:cs typeface="Calibri" pitchFamily="34" charset="-120"/>
+              </a:rPr>
+              <a:t>Compliance</a:t>
+            </a:r>
+            <a:endParaRPr lang="en-US" sz="1550" dirty="0"/>
+          </a:p>
+        </p:txBody>
+      </p:sp>
+      <p:sp>
+        <p:nvSpPr>
+          <p:cNvPr id="10" name="Text 8"/>
+          <p:cNvSpPr/>
+          <p:nvPr/>
+        </p:nvSpPr>
+        <p:spPr>
+          <a:xfrm>
+            <a:off x="1005840" y="3685032"/>
+            <a:ext cx="4663440" cy="365760"/>
+          </a:xfrm>
+          <a:prstGeom prst="rect">
+            <a:avLst/>
+          </a:prstGeom>
+          <a:noFill/>
+          <a:ln/>
+        </p:spPr>
+        <p:txBody>
+          <a:bodyPr wrap="square" rtlCol="0" anchor="ctr"/>
+          <a:lstStyle/>
+          <a:p>
+            <a:pPr indent="0" marL="0">
+              <a:buNone/>
+            </a:pPr>
+            <a:r>
+              <a:rPr lang="en-US" sz="1300" dirty="0">
+                <a:solidFill>
+                  <a:srgbClr val="5B6570"/>
+                </a:solidFill>
+                <a:latin typeface="Calibri" pitchFamily="34" charset="0"/>
+                <a:ea typeface="Calibri" pitchFamily="34" charset="-122"/>
+                <a:cs typeface="Calibri" pitchFamily="34" charset="-120"/>
+              </a:rPr>
+              <a:t>GDPR requires EU customer data to stay in the EU</a:t>
+            </a:r>
+            <a:endParaRPr lang="en-US" sz="1300" dirty="0"/>
+          </a:p>
+        </p:txBody>
+      </p:sp>
+      <p:sp>
+        <p:nvSpPr>
+          <p:cNvPr id="11" name="Text 9"/>
+          <p:cNvSpPr/>
+          <p:nvPr/>
+        </p:nvSpPr>
+        <p:spPr>
+          <a:xfrm>
+            <a:off x="1005840" y="4160520"/>
+            <a:ext cx="4663440" cy="320040"/>
+          </a:xfrm>
+          <a:prstGeom prst="rect">
+            <a:avLst/>
+          </a:prstGeom>
+          <a:noFill/>
+          <a:ln/>
+        </p:spPr>
+        <p:txBody>
+          <a:bodyPr wrap="square" rtlCol="0" anchor="ctr"/>
+          <a:lstStyle/>
+          <a:p>
+            <a:pPr indent="0" marL="0">
+              <a:buNone/>
+            </a:pPr>
+            <a:r>
+              <a:rPr lang="en-US" sz="1550" b="1" dirty="0">
+                <a:solidFill>
+                  <a:srgbClr val="232F3E"/>
+                </a:solidFill>
+                <a:latin typeface="Calibri" pitchFamily="34" charset="0"/>
+                <a:ea typeface="Calibri" pitchFamily="34" charset="-122"/>
+                <a:cs typeface="Calibri" pitchFamily="34" charset="-120"/>
+              </a:rPr>
+              <a:t>Price</a:t>
+            </a:r>
+            <a:endParaRPr lang="en-US" sz="1550" dirty="0"/>
+          </a:p>
+        </p:txBody>
+      </p:sp>
+      <p:sp>
+        <p:nvSpPr>
+          <p:cNvPr id="12" name="Text 10"/>
+          <p:cNvSpPr/>
+          <p:nvPr/>
+        </p:nvSpPr>
+        <p:spPr>
+          <a:xfrm>
+            <a:off x="1005840" y="4462272"/>
+            <a:ext cx="4663440" cy="365760"/>
+          </a:xfrm>
+          <a:prstGeom prst="rect">
+            <a:avLst/>
+          </a:prstGeom>
+          <a:noFill/>
+          <a:ln/>
+        </p:spPr>
+        <p:txBody>
+          <a:bodyPr wrap="square" rtlCol="0" anchor="ctr"/>
+          <a:lstStyle/>
+          <a:p>
+            <a:pPr indent="0" marL="0">
+              <a:buNone/>
+            </a:pPr>
+            <a:r>
+              <a:rPr lang="en-US" sz="1300" dirty="0">
+                <a:solidFill>
+                  <a:srgbClr val="5B6570"/>
+                </a:solidFill>
+                <a:latin typeface="Calibri" pitchFamily="34" charset="0"/>
+                <a:ea typeface="Calibri" pitchFamily="34" charset="-122"/>
+                <a:cs typeface="Calibri" pitchFamily="34" charset="-120"/>
+              </a:rPr>
+              <a:t>No stated budget constraint, but leadership wants to avoid overpaying</a:t>
+            </a:r>
+            <a:endParaRPr lang="en-US" sz="1300" dirty="0"/>
+          </a:p>
+        </p:txBody>
+      </p:sp>
+      <p:sp>
+        <p:nvSpPr>
+          <p:cNvPr id="13" name="Text 11"/>
+          <p:cNvSpPr/>
+          <p:nvPr/>
+        </p:nvSpPr>
+        <p:spPr>
+          <a:xfrm>
+            <a:off x="1005840" y="4937760"/>
+            <a:ext cx="4663440" cy="320040"/>
+          </a:xfrm>
+          <a:prstGeom prst="rect">
+            <a:avLst/>
+          </a:prstGeom>
+          <a:noFill/>
+          <a:ln/>
+        </p:spPr>
+        <p:txBody>
+          <a:bodyPr wrap="square" rtlCol="0" anchor="ctr"/>
+          <a:lstStyle/>
+          <a:p>
+            <a:pPr indent="0" marL="0">
+              <a:buNone/>
+            </a:pPr>
+            <a:r>
+              <a:rPr lang="en-US" sz="1550" b="1" dirty="0">
+                <a:solidFill>
+                  <a:srgbClr val="232F3E"/>
+                </a:solidFill>
+                <a:latin typeface="Calibri" pitchFamily="34" charset="0"/>
+                <a:ea typeface="Calibri" pitchFamily="34" charset="-122"/>
+                <a:cs typeface="Calibri" pitchFamily="34" charset="-120"/>
+              </a:rPr>
+              <a:t>Service availability</a:t>
+            </a:r>
+            <a:endParaRPr lang="en-US" sz="1550" dirty="0"/>
+          </a:p>
+        </p:txBody>
+      </p:sp>
+      <p:sp>
+        <p:nvSpPr>
+          <p:cNvPr id="14" name="Text 12"/>
+          <p:cNvSpPr/>
+          <p:nvPr/>
+        </p:nvSpPr>
+        <p:spPr>
+          <a:xfrm>
+            <a:off x="1005840" y="5239512"/>
+            <a:ext cx="4663440" cy="365760"/>
+          </a:xfrm>
+          <a:prstGeom prst="rect">
+            <a:avLst/>
+          </a:prstGeom>
+          <a:noFill/>
+          <a:ln/>
+        </p:spPr>
+        <p:txBody>
+          <a:bodyPr wrap="square" rtlCol="0" anchor="ctr"/>
+          <a:lstStyle/>
+          <a:p>
+            <a:pPr indent="0" marL="0">
+              <a:buNone/>
+            </a:pPr>
+            <a:r>
+              <a:rPr lang="en-US" sz="1300" dirty="0">
+                <a:solidFill>
+                  <a:srgbClr val="5B6570"/>
+                </a:solidFill>
+                <a:latin typeface="Calibri" pitchFamily="34" charset="0"/>
+                <a:ea typeface="Calibri" pitchFamily="34" charset="-122"/>
+                <a:cs typeface="Calibri" pitchFamily="34" charset="-120"/>
+              </a:rPr>
+              <a:t>Needs CloudFront, S3, and a standard database — all widely available</a:t>
+            </a:r>
+            <a:endParaRPr lang="en-US" sz="1300" dirty="0"/>
+          </a:p>
+        </p:txBody>
+      </p:sp>
+      <p:sp>
+        <p:nvSpPr>
+          <p:cNvPr id="15" name="Shape 13"/>
+          <p:cNvSpPr/>
+          <p:nvPr/>
+        </p:nvSpPr>
+        <p:spPr>
+          <a:xfrm>
+            <a:off x="6355080" y="1920240"/>
+            <a:ext cx="5166360" cy="3794760"/>
+          </a:xfrm>
+          <a:prstGeom prst="roundRect">
+            <a:avLst>
+              <a:gd name="adj" fmla="val 2892"/>
+            </a:avLst>
+          </a:prstGeom>
+          <a:solidFill>
+            <a:srgbClr val="232F3E"/>
+          </a:solidFill>
+          <a:ln/>
+        </p:spPr>
+      </p:sp>
+      <p:sp>
+        <p:nvSpPr>
+          <p:cNvPr id="16" name="Text 14"/>
+          <p:cNvSpPr/>
+          <p:nvPr/>
+        </p:nvSpPr>
+        <p:spPr>
+          <a:xfrm>
+            <a:off x="6720840" y="2148840"/>
+            <a:ext cx="4480560" cy="320040"/>
+          </a:xfrm>
+          <a:prstGeom prst="rect">
+            <a:avLst/>
+          </a:prstGeom>
+          <a:noFill/>
+          <a:ln/>
+        </p:spPr>
+        <p:txBody>
+          <a:bodyPr wrap="square" rtlCol="0" anchor="ctr"/>
+          <a:lstStyle/>
+          <a:p>
+            <a:pPr indent="0" marL="0">
+              <a:buNone/>
+            </a:pPr>
+            <a:r>
+              <a:rPr lang="en-US" sz="1200" b="1" spc="200" kern="0" dirty="0">
+                <a:solidFill>
+                  <a:srgbClr val="FF9900"/>
+                </a:solidFill>
+                <a:latin typeface="Calibri" pitchFamily="34" charset="0"/>
+                <a:ea typeface="Calibri" pitchFamily="34" charset="-122"/>
+                <a:cs typeface="Calibri" pitchFamily="34" charset="-120"/>
+              </a:rPr>
+              <a:t>APPLY THE FACTORS</a:t>
+            </a:r>
+            <a:endParaRPr lang="en-US" sz="1200" dirty="0"/>
+          </a:p>
+        </p:txBody>
+      </p:sp>
+      <p:sp>
+        <p:nvSpPr>
+          <p:cNvPr id="17" name="Text 15"/>
+          <p:cNvSpPr/>
+          <p:nvPr/>
+        </p:nvSpPr>
+        <p:spPr>
+          <a:xfrm>
+            <a:off x="6720840" y="2560320"/>
+            <a:ext cx="4480560" cy="777240"/>
+          </a:xfrm>
+          <a:prstGeom prst="rect">
+            <a:avLst/>
+          </a:prstGeom>
+          <a:noFill/>
+          <a:ln/>
+        </p:spPr>
+        <p:txBody>
+          <a:bodyPr wrap="square" rtlCol="0" anchor="ctr"/>
+          <a:lstStyle/>
+          <a:p>
+            <a:pPr indent="0" marL="0">
+              <a:lnSpc>
+                <a:spcPct val="98000"/>
+              </a:lnSpc>
+              <a:buNone/>
+            </a:pPr>
+            <a:r>
+              <a:rPr lang="en-US" sz="2100" b="1" dirty="0">
+                <a:solidFill>
+                  <a:srgbClr val="FFFFFF"/>
+                </a:solidFill>
+                <a:latin typeface="Calibri" pitchFamily="34" charset="0"/>
+                <a:ea typeface="Calibri" pitchFamily="34" charset="-122"/>
+                <a:cs typeface="Calibri" pitchFamily="34" charset="-120"/>
+              </a:rPr>
+              <a:t>Region: eu-central-1 (Frankfurt)</a:t>
+            </a:r>
+            <a:endParaRPr lang="en-US" sz="2100" dirty="0"/>
+          </a:p>
+        </p:txBody>
+      </p:sp>
+      <p:sp>
+        <p:nvSpPr>
+          <p:cNvPr id="18" name="Text 16"/>
+          <p:cNvSpPr/>
+          <p:nvPr/>
+        </p:nvSpPr>
+        <p:spPr>
+          <a:xfrm>
+            <a:off x="6720840" y="3474720"/>
+            <a:ext cx="4480560" cy="2011680"/>
+          </a:xfrm>
+          <a:prstGeom prst="rect">
+            <a:avLst/>
+          </a:prstGeom>
+          <a:noFill/>
+          <a:ln/>
+        </p:spPr>
+        <p:txBody>
+          <a:bodyPr wrap="square" rtlCol="0" anchor="ctr"/>
+          <a:lstStyle/>
+          <a:p>
+            <a:pPr indent="0" marL="0">
+              <a:lnSpc>
+                <a:spcPct val="106000"/>
+              </a:lnSpc>
+              <a:buNone/>
+            </a:pPr>
+            <a:r>
+              <a:rPr lang="en-US" sz="1400" dirty="0">
+                <a:solidFill>
+                  <a:srgbClr val="C7D2DE"/>
+                </a:solidFill>
+                <a:latin typeface="Calibri" pitchFamily="34" charset="0"/>
+                <a:ea typeface="Calibri" pitchFamily="34" charset="-122"/>
+                <a:cs typeface="Calibri" pitchFamily="34" charset="-120"/>
+              </a:rPr>
+              <a:t>Compliance settles it before latency or price even get a vote — GDPR isn’t optional, and Frankfurt happens to satisfy latency too as a bonus.</a:t>
+            </a:r>
+            <a:endParaRPr lang="en-US" sz="1400" dirty="0"/>
+          </a:p>
+          <a:p>
+            <a:pPr indent="0" marL="0">
+              <a:lnSpc>
+                <a:spcPct val="106000"/>
+              </a:lnSpc>
+              <a:buNone/>
+            </a:pPr>
+            <a:endParaRPr lang="en-US" sz="1400" dirty="0"/>
+          </a:p>
+          <a:p>
+            <a:pPr indent="0" marL="0">
+              <a:lnSpc>
+                <a:spcPct val="106000"/>
+              </a:lnSpc>
+              <a:buNone/>
+            </a:pPr>
+            <a:r>
+              <a:rPr lang="en-US" sz="1400" dirty="0">
+                <a:solidFill>
+                  <a:srgbClr val="C7D2DE"/>
+                </a:solidFill>
+                <a:latin typeface="Calibri" pitchFamily="34" charset="0"/>
+                <a:ea typeface="Calibri" pitchFamily="34" charset="-122"/>
+                <a:cs typeface="Calibri" pitchFamily="34" charset="-120"/>
+              </a:rPr>
+              <a:t>Notice the order: compliance was non-negotiable, and everything else fell into place around it.</a:t>
+            </a:r>
+            <a:endParaRPr lang="en-US" sz="1400" dirty="0"/>
+          </a:p>
+        </p:txBody>
+      </p:sp>
+      <p:sp>
+        <p:nvSpPr>
+          <p:cNvPr id="19" name="Text 17"/>
+          <p:cNvSpPr/>
+          <p:nvPr/>
+        </p:nvSpPr>
+        <p:spPr>
+          <a:xfrm>
+            <a:off x="640080" y="6473952"/>
+            <a:ext cx="5943600" cy="274320"/>
+          </a:xfrm>
+          <a:prstGeom prst="rect">
+            <a:avLst/>
+          </a:prstGeom>
+          <a:noFill/>
+          <a:ln/>
+        </p:spPr>
+        <p:txBody>
+          <a:bodyPr wrap="square" rtlCol="0" anchor="ctr"/>
+          <a:lstStyle/>
+          <a:p>
+            <a:pPr indent="0" marL="0">
+              <a:buNone/>
+            </a:pPr>
+            <a:r>
+              <a:rPr lang="en-US" sz="900" dirty="0">
+                <a:solidFill>
+                  <a:srgbClr val="5B6570"/>
+                </a:solidFill>
+                <a:latin typeface="Calibri" pitchFamily="34" charset="0"/>
+                <a:ea typeface="Calibri" pitchFamily="34" charset="-122"/>
+                <a:cs typeface="Calibri" pitchFamily="34" charset="-120"/>
+              </a:rPr>
+              <a:t>AWS SAA-A  ·  Lecture 3  ·  AWS Global Infrastructure Overview</a:t>
+            </a:r>
+            <a:endParaRPr lang="en-US" sz="900" dirty="0"/>
+          </a:p>
+        </p:txBody>
+      </p:sp>
+      <p:sp>
+        <p:nvSpPr>
+          <p:cNvPr id="20" name="Text 18"/>
+          <p:cNvSpPr/>
+          <p:nvPr/>
+        </p:nvSpPr>
+        <p:spPr>
+          <a:xfrm>
+            <a:off x="11000232" y="6473952"/>
+            <a:ext cx="548640" cy="274320"/>
+          </a:xfrm>
+          <a:prstGeom prst="rect">
+            <a:avLst/>
+          </a:prstGeom>
+          <a:noFill/>
+          <a:ln/>
+        </p:spPr>
+        <p:txBody>
+          <a:bodyPr wrap="square" rtlCol="0" anchor="ctr"/>
+          <a:lstStyle/>
+          <a:p>
+            <a:pPr algn="r" indent="0" marL="0">
+              <a:buNone/>
+            </a:pPr>
+            <a:r>
+              <a:rPr lang="en-US" sz="900" dirty="0">
+                <a:solidFill>
+                  <a:srgbClr val="5B6570"/>
+                </a:solidFill>
+                <a:latin typeface="Calibri" pitchFamily="34" charset="0"/>
+                <a:ea typeface="Calibri" pitchFamily="34" charset="-122"/>
+                <a:cs typeface="Calibri" pitchFamily="34" charset="-120"/>
+              </a:rPr>
+              <a:t>13</a:t>
+            </a:r>
+            <a:endParaRPr lang="en-US" sz="900" dirty="0"/>
+          </a:p>
+        </p:txBody>
+      </p:sp>
+    </p:spTree>
+  </p:cSld>
+  <p:clrMapOvr>
+    <a:masterClrMapping/>
+  </p:clrMapOvr>
+</p:sld>
+</file>
+
+<file path=ppt/slides/slide37.xml><?xml version="1.0" encoding="utf-8"?>
+<p:sld xmlns:a="http://schemas.openxmlformats.org/drawingml/2006/main" xmlns:r="http://schemas.openxmlformats.org/officeDocument/2006/relationships" xmlns:p="http://schemas.openxmlformats.org/presentationml/2006/main">
+  <p:cSld name="Slide 13">
+    <p:bg>
+      <p:bgPr>
+        <a:solidFill>
+          <a:srgbClr val="F4F6F8"/>
+        </a:solidFill>
+      </p:bgPr>
+    </p:bg>
+    <p:spTree>
+      <p:nvGrpSpPr>
+        <p:cNvPr id="1" name=""/>
+        <p:cNvGrpSpPr/>
+        <p:nvPr/>
+      </p:nvGrpSpPr>
+      <p:grpSpPr>
+        <a:xfrm>
+          <a:off x="0" y="0"/>
+          <a:ext cx="0" cy="0"/>
+          <a:chOff x="0" y="0"/>
+          <a:chExt cx="0" cy="0"/>
+        </a:xfrm>
+      </p:grpSpPr>
+      <p:sp>
+        <p:nvSpPr>
+          <p:cNvPr id="2" name="Text 0"/>
+          <p:cNvSpPr/>
+          <p:nvPr/>
+        </p:nvSpPr>
+        <p:spPr>
+          <a:xfrm>
+            <a:off x="640080" y="457200"/>
+            <a:ext cx="10908792" cy="274320"/>
+          </a:xfrm>
+          <a:prstGeom prst="rect">
+            <a:avLst/>
+          </a:prstGeom>
+          <a:noFill/>
+          <a:ln/>
+        </p:spPr>
+        <p:txBody>
+          <a:bodyPr wrap="square" rtlCol="0" anchor="ctr"/>
+          <a:lstStyle/>
+          <a:p>
+            <a:pPr indent="0" marL="0">
+              <a:buNone/>
+            </a:pPr>
+            <a:r>
+              <a:rPr lang="en-US" sz="1200" b="1" spc="200" kern="0" dirty="0">
+                <a:solidFill>
+                  <a:srgbClr val="EC7211"/>
+                </a:solidFill>
+                <a:latin typeface="Calibri" pitchFamily="34" charset="0"/>
+                <a:ea typeface="Calibri" pitchFamily="34" charset="-122"/>
+                <a:cs typeface="Calibri" pitchFamily="34" charset="-120"/>
+              </a:rPr>
+              <a:t>BEFORE WE OPEN THE CONSOLE</a:t>
+            </a:r>
+            <a:endParaRPr lang="en-US" sz="1200" dirty="0"/>
+          </a:p>
+        </p:txBody>
+      </p:sp>
+      <p:sp>
+        <p:nvSpPr>
+          <p:cNvPr id="3" name="Text 1"/>
+          <p:cNvSpPr/>
+          <p:nvPr/>
+        </p:nvSpPr>
+        <p:spPr>
+          <a:xfrm>
+            <a:off x="640080" y="731520"/>
+            <a:ext cx="10908792" cy="640080"/>
+          </a:xfrm>
+          <a:prstGeom prst="rect">
+            <a:avLst/>
+          </a:prstGeom>
+          <a:noFill/>
+          <a:ln/>
+        </p:spPr>
+        <p:txBody>
+          <a:bodyPr wrap="square" rtlCol="0" anchor="ctr"/>
+          <a:lstStyle/>
+          <a:p>
+            <a:pPr indent="0" marL="0">
+              <a:buNone/>
+            </a:pPr>
+            <a:r>
+              <a:rPr lang="en-US" sz="3200" b="1" dirty="0">
+                <a:solidFill>
+                  <a:srgbClr val="232F3E"/>
+                </a:solidFill>
+                <a:latin typeface="Calibri" pitchFamily="34" charset="0"/>
+                <a:ea typeface="Calibri" pitchFamily="34" charset="-122"/>
+                <a:cs typeface="Calibri" pitchFamily="34" charset="-120"/>
+              </a:rPr>
+              <a:t>Console Preview: Finding Your Infrastructure</a:t>
+            </a:r>
+            <a:endParaRPr lang="en-US" sz="3200" dirty="0"/>
+          </a:p>
+        </p:txBody>
+      </p:sp>
+      <p:sp>
+        <p:nvSpPr>
+          <p:cNvPr id="4" name="Text 2"/>
+          <p:cNvSpPr/>
+          <p:nvPr/>
+        </p:nvSpPr>
+        <p:spPr>
+          <a:xfrm>
+            <a:off x="640080" y="1417320"/>
+            <a:ext cx="10908792" cy="365760"/>
+          </a:xfrm>
+          <a:prstGeom prst="rect">
+            <a:avLst/>
+          </a:prstGeom>
+          <a:noFill/>
+          <a:ln/>
+        </p:spPr>
+        <p:txBody>
+          <a:bodyPr wrap="square" rtlCol="0" anchor="ctr"/>
+          <a:lstStyle/>
+          <a:p>
+            <a:pPr indent="0" marL="0">
+              <a:buNone/>
+            </a:pPr>
+            <a:r>
+              <a:rPr lang="en-US" sz="1500" i="1" dirty="0">
+                <a:solidFill>
+                  <a:srgbClr val="5B6570"/>
+                </a:solidFill>
+                <a:latin typeface="Calibri" pitchFamily="34" charset="0"/>
+                <a:ea typeface="Calibri" pitchFamily="34" charset="-122"/>
+                <a:cs typeface="Calibri" pitchFamily="34" charset="-120"/>
+              </a:rPr>
+              <a:t>You don’t have to guess where infrastructure concepts live in the AWS Console. Here’s where to look tonight.</a:t>
+            </a:r>
+            <a:endParaRPr lang="en-US" sz="1500" dirty="0"/>
+          </a:p>
+        </p:txBody>
+      </p:sp>
+      <p:sp>
+        <p:nvSpPr>
+          <p:cNvPr id="5" name="Shape 3"/>
+          <p:cNvSpPr/>
+          <p:nvPr/>
+        </p:nvSpPr>
+        <p:spPr>
+          <a:xfrm>
+            <a:off x="640080" y="1965960"/>
+            <a:ext cx="3483864" cy="1828800"/>
+          </a:xfrm>
+          <a:prstGeom prst="roundRect">
+            <a:avLst>
+              <a:gd name="adj" fmla="val 5000"/>
+            </a:avLst>
+          </a:prstGeom>
+          <a:solidFill>
+            <a:srgbClr val="FFFFFF"/>
+          </a:solidFill>
+          <a:ln w="12700">
+            <a:solidFill>
+              <a:srgbClr val="DCE1E6"/>
+            </a:solidFill>
+            <a:prstDash val="solid"/>
+          </a:ln>
+          <a:effectLst>
+            <a:outerShdw sx="100000" sy="100000" kx="0" ky="0" algn="bl" rotWithShape="0" blurRad="88900" dist="25400" dir="5400000">
+              <a:srgbClr val="CBD2D8">
+                <a:alpha val="50000"/>
+              </a:srgbClr>
+            </a:outerShdw>
+          </a:effectLst>
+        </p:spPr>
+      </p:sp>
+      <p:sp>
+        <p:nvSpPr>
+          <p:cNvPr id="6" name="Shape 4"/>
+          <p:cNvSpPr/>
+          <p:nvPr/>
+        </p:nvSpPr>
+        <p:spPr>
+          <a:xfrm>
+            <a:off x="640080" y="1965960"/>
+            <a:ext cx="137160" cy="1828800"/>
+          </a:xfrm>
+          <a:prstGeom prst="roundRect">
+            <a:avLst>
+              <a:gd name="adj" fmla="val 13333"/>
+            </a:avLst>
+          </a:prstGeom>
+          <a:solidFill>
+            <a:srgbClr val="EC7211"/>
+          </a:solidFill>
+          <a:ln/>
+        </p:spPr>
+      </p:sp>
+      <p:sp>
+        <p:nvSpPr>
+          <p:cNvPr id="7" name="Text 5"/>
+          <p:cNvSpPr/>
+          <p:nvPr/>
+        </p:nvSpPr>
+        <p:spPr>
+          <a:xfrm>
+            <a:off x="1005840" y="2167128"/>
+            <a:ext cx="2889504" cy="457200"/>
+          </a:xfrm>
+          <a:prstGeom prst="rect">
+            <a:avLst/>
+          </a:prstGeom>
+          <a:noFill/>
+          <a:ln/>
+        </p:spPr>
+        <p:txBody>
+          <a:bodyPr wrap="square" rtlCol="0" anchor="ctr"/>
+          <a:lstStyle/>
+          <a:p>
+            <a:pPr indent="0" marL="0">
+              <a:lnSpc>
+                <a:spcPct val="95000"/>
+              </a:lnSpc>
+              <a:buNone/>
+            </a:pPr>
+            <a:r>
+              <a:rPr lang="en-US" sz="1600" b="1" dirty="0">
+                <a:solidFill>
+                  <a:srgbClr val="232F3E"/>
+                </a:solidFill>
+                <a:latin typeface="Calibri" pitchFamily="34" charset="0"/>
+                <a:ea typeface="Calibri" pitchFamily="34" charset="-122"/>
+                <a:cs typeface="Calibri" pitchFamily="34" charset="-120"/>
+              </a:rPr>
+              <a:t>Region selector</a:t>
+            </a:r>
+            <a:endParaRPr lang="en-US" sz="1600" dirty="0"/>
+          </a:p>
+        </p:txBody>
+      </p:sp>
+      <p:sp>
+        <p:nvSpPr>
+          <p:cNvPr id="8" name="Text 6"/>
+          <p:cNvSpPr/>
+          <p:nvPr/>
+        </p:nvSpPr>
+        <p:spPr>
+          <a:xfrm>
+            <a:off x="1005840" y="2697480"/>
+            <a:ext cx="2843784" cy="914400"/>
+          </a:xfrm>
+          <a:prstGeom prst="rect">
+            <a:avLst/>
+          </a:prstGeom>
+          <a:noFill/>
+          <a:ln/>
+        </p:spPr>
+        <p:txBody>
+          <a:bodyPr wrap="square" rtlCol="0" anchor="ctr"/>
+          <a:lstStyle/>
+          <a:p>
+            <a:pPr indent="0" marL="0">
+              <a:lnSpc>
+                <a:spcPct val="103000"/>
+              </a:lnSpc>
+              <a:buNone/>
+            </a:pPr>
+            <a:r>
+              <a:rPr lang="en-US" sz="1300" dirty="0">
+                <a:solidFill>
+                  <a:srgbClr val="5B6570"/>
+                </a:solidFill>
+                <a:latin typeface="Calibri" pitchFamily="34" charset="0"/>
+                <a:ea typeface="Calibri" pitchFamily="34" charset="-122"/>
+                <a:cs typeface="Calibri" pitchFamily="34" charset="-120"/>
+              </a:rPr>
+              <a:t>Top-right corner of every console page — this is the Region you’re currently working in.</a:t>
+            </a:r>
+            <a:endParaRPr lang="en-US" sz="1300" dirty="0"/>
+          </a:p>
+        </p:txBody>
+      </p:sp>
+      <p:sp>
+        <p:nvSpPr>
+          <p:cNvPr id="9" name="Shape 7"/>
+          <p:cNvSpPr/>
+          <p:nvPr/>
+        </p:nvSpPr>
+        <p:spPr>
+          <a:xfrm>
+            <a:off x="4352544" y="1965960"/>
+            <a:ext cx="3483864" cy="1828800"/>
+          </a:xfrm>
+          <a:prstGeom prst="roundRect">
+            <a:avLst>
+              <a:gd name="adj" fmla="val 5000"/>
+            </a:avLst>
+          </a:prstGeom>
+          <a:solidFill>
+            <a:srgbClr val="FFFFFF"/>
+          </a:solidFill>
+          <a:ln w="12700">
+            <a:solidFill>
+              <a:srgbClr val="DCE1E6"/>
+            </a:solidFill>
+            <a:prstDash val="solid"/>
+          </a:ln>
+          <a:effectLst>
+            <a:outerShdw sx="100000" sy="100000" kx="0" ky="0" algn="bl" rotWithShape="0" blurRad="88900" dist="25400" dir="5400000">
+              <a:srgbClr val="CBD2D8">
+                <a:alpha val="50000"/>
+              </a:srgbClr>
+            </a:outerShdw>
+          </a:effectLst>
+        </p:spPr>
+      </p:sp>
+      <p:sp>
+        <p:nvSpPr>
+          <p:cNvPr id="10" name="Shape 8"/>
+          <p:cNvSpPr/>
+          <p:nvPr/>
+        </p:nvSpPr>
+        <p:spPr>
+          <a:xfrm>
+            <a:off x="4352544" y="1965960"/>
+            <a:ext cx="137160" cy="1828800"/>
+          </a:xfrm>
+          <a:prstGeom prst="roundRect">
+            <a:avLst>
+              <a:gd name="adj" fmla="val 13333"/>
+            </a:avLst>
+          </a:prstGeom>
+          <a:solidFill>
+            <a:srgbClr val="1F8A38"/>
+          </a:solidFill>
+          <a:ln/>
+        </p:spPr>
+      </p:sp>
+      <p:sp>
+        <p:nvSpPr>
+          <p:cNvPr id="11" name="Text 9"/>
+          <p:cNvSpPr/>
+          <p:nvPr/>
+        </p:nvSpPr>
+        <p:spPr>
+          <a:xfrm>
+            <a:off x="4718304" y="2167128"/>
+            <a:ext cx="2889504" cy="457200"/>
+          </a:xfrm>
+          <a:prstGeom prst="rect">
+            <a:avLst/>
+          </a:prstGeom>
+          <a:noFill/>
+          <a:ln/>
+        </p:spPr>
+        <p:txBody>
+          <a:bodyPr wrap="square" rtlCol="0" anchor="ctr"/>
+          <a:lstStyle/>
+          <a:p>
+            <a:pPr indent="0" marL="0">
+              <a:lnSpc>
+                <a:spcPct val="95000"/>
+              </a:lnSpc>
+              <a:buNone/>
+            </a:pPr>
+            <a:r>
+              <a:rPr lang="en-US" sz="1600" b="1" dirty="0">
+                <a:solidFill>
+                  <a:srgbClr val="232F3E"/>
+                </a:solidFill>
+                <a:latin typeface="Calibri" pitchFamily="34" charset="0"/>
+                <a:ea typeface="Calibri" pitchFamily="34" charset="-122"/>
+                <a:cs typeface="Calibri" pitchFamily="34" charset="-120"/>
+              </a:rPr>
+              <a:t>AZ picker</a:t>
+            </a:r>
+            <a:endParaRPr lang="en-US" sz="1600" dirty="0"/>
+          </a:p>
+        </p:txBody>
+      </p:sp>
+      <p:sp>
+        <p:nvSpPr>
+          <p:cNvPr id="12" name="Text 10"/>
+          <p:cNvSpPr/>
+          <p:nvPr/>
+        </p:nvSpPr>
+        <p:spPr>
+          <a:xfrm>
+            <a:off x="4718304" y="2697480"/>
+            <a:ext cx="2843784" cy="914400"/>
+          </a:xfrm>
+          <a:prstGeom prst="rect">
+            <a:avLst/>
+          </a:prstGeom>
+          <a:noFill/>
+          <a:ln/>
+        </p:spPr>
+        <p:txBody>
+          <a:bodyPr wrap="square" rtlCol="0" anchor="ctr"/>
+          <a:lstStyle/>
+          <a:p>
+            <a:pPr indent="0" marL="0">
+              <a:lnSpc>
+                <a:spcPct val="103000"/>
+              </a:lnSpc>
+              <a:buNone/>
+            </a:pPr>
+            <a:r>
+              <a:rPr lang="en-US" sz="1300" dirty="0">
+                <a:solidFill>
+                  <a:srgbClr val="5B6570"/>
+                </a:solidFill>
+                <a:latin typeface="Calibri" pitchFamily="34" charset="0"/>
+                <a:ea typeface="Calibri" pitchFamily="34" charset="-122"/>
+                <a:cs typeface="Calibri" pitchFamily="34" charset="-120"/>
+              </a:rPr>
+              <a:t>Shows up when launching an EC2 instance or creating a subnet — you choose the AZ there.</a:t>
+            </a:r>
+            <a:endParaRPr lang="en-US" sz="1300" dirty="0"/>
+          </a:p>
+        </p:txBody>
+      </p:sp>
+      <p:sp>
+        <p:nvSpPr>
+          <p:cNvPr id="13" name="Shape 11"/>
+          <p:cNvSpPr/>
+          <p:nvPr/>
+        </p:nvSpPr>
+        <p:spPr>
+          <a:xfrm>
+            <a:off x="8065008" y="1965960"/>
+            <a:ext cx="3483864" cy="1828800"/>
+          </a:xfrm>
+          <a:prstGeom prst="roundRect">
+            <a:avLst>
+              <a:gd name="adj" fmla="val 5000"/>
+            </a:avLst>
+          </a:prstGeom>
+          <a:solidFill>
+            <a:srgbClr val="FFFFFF"/>
+          </a:solidFill>
+          <a:ln w="12700">
+            <a:solidFill>
+              <a:srgbClr val="DCE1E6"/>
+            </a:solidFill>
+            <a:prstDash val="solid"/>
+          </a:ln>
+          <a:effectLst>
+            <a:outerShdw sx="100000" sy="100000" kx="0" ky="0" algn="bl" rotWithShape="0" blurRad="88900" dist="25400" dir="5400000">
+              <a:srgbClr val="CBD2D8">
+                <a:alpha val="50000"/>
+              </a:srgbClr>
+            </a:outerShdw>
+          </a:effectLst>
+        </p:spPr>
+      </p:sp>
+      <p:sp>
+        <p:nvSpPr>
+          <p:cNvPr id="14" name="Shape 12"/>
+          <p:cNvSpPr/>
+          <p:nvPr/>
+        </p:nvSpPr>
+        <p:spPr>
+          <a:xfrm>
+            <a:off x="8065008" y="1965960"/>
+            <a:ext cx="137160" cy="1828800"/>
+          </a:xfrm>
+          <a:prstGeom prst="roundRect">
+            <a:avLst>
+              <a:gd name="adj" fmla="val 13333"/>
+            </a:avLst>
+          </a:prstGeom>
+          <a:solidFill>
+            <a:srgbClr val="1E8FA5"/>
+          </a:solidFill>
+          <a:ln/>
+        </p:spPr>
+      </p:sp>
+      <p:sp>
+        <p:nvSpPr>
+          <p:cNvPr id="15" name="Text 13"/>
+          <p:cNvSpPr/>
+          <p:nvPr/>
+        </p:nvSpPr>
+        <p:spPr>
+          <a:xfrm>
+            <a:off x="8430768" y="2167128"/>
+            <a:ext cx="2889504" cy="457200"/>
+          </a:xfrm>
+          <a:prstGeom prst="rect">
+            <a:avLst/>
+          </a:prstGeom>
+          <a:noFill/>
+          <a:ln/>
+        </p:spPr>
+        <p:txBody>
+          <a:bodyPr wrap="square" rtlCol="0" anchor="ctr"/>
+          <a:lstStyle/>
+          <a:p>
+            <a:pPr indent="0" marL="0">
+              <a:lnSpc>
+                <a:spcPct val="95000"/>
+              </a:lnSpc>
+              <a:buNone/>
+            </a:pPr>
+            <a:r>
+              <a:rPr lang="en-US" sz="1600" b="1" dirty="0">
+                <a:solidFill>
+                  <a:srgbClr val="232F3E"/>
+                </a:solidFill>
+                <a:latin typeface="Calibri" pitchFamily="34" charset="0"/>
+                <a:ea typeface="Calibri" pitchFamily="34" charset="-122"/>
+                <a:cs typeface="Calibri" pitchFamily="34" charset="-120"/>
+              </a:rPr>
+              <a:t>CloudFront distributions</a:t>
+            </a:r>
+            <a:endParaRPr lang="en-US" sz="1600" dirty="0"/>
+          </a:p>
+        </p:txBody>
+      </p:sp>
+      <p:sp>
+        <p:nvSpPr>
+          <p:cNvPr id="16" name="Text 14"/>
+          <p:cNvSpPr/>
+          <p:nvPr/>
+        </p:nvSpPr>
+        <p:spPr>
+          <a:xfrm>
+            <a:off x="8430768" y="2697480"/>
+            <a:ext cx="2843784" cy="914400"/>
+          </a:xfrm>
+          <a:prstGeom prst="rect">
+            <a:avLst/>
+          </a:prstGeom>
+          <a:noFill/>
+          <a:ln/>
+        </p:spPr>
+        <p:txBody>
+          <a:bodyPr wrap="square" rtlCol="0" anchor="ctr"/>
+          <a:lstStyle/>
+          <a:p>
+            <a:pPr indent="0" marL="0">
+              <a:lnSpc>
+                <a:spcPct val="103000"/>
+              </a:lnSpc>
+              <a:buNone/>
+            </a:pPr>
+            <a:r>
+              <a:rPr lang="en-US" sz="1300" dirty="0">
+                <a:solidFill>
+                  <a:srgbClr val="5B6570"/>
+                </a:solidFill>
+                <a:latin typeface="Calibri" pitchFamily="34" charset="0"/>
+                <a:ea typeface="Calibri" pitchFamily="34" charset="-122"/>
+                <a:cs typeface="Calibri" pitchFamily="34" charset="-120"/>
+              </a:rPr>
+              <a:t>Its own service console — where you create and manage edge caching.</a:t>
+            </a:r>
+            <a:endParaRPr lang="en-US" sz="1300" dirty="0"/>
+          </a:p>
+        </p:txBody>
+      </p:sp>
+      <p:sp>
+        <p:nvSpPr>
+          <p:cNvPr id="17" name="Shape 15"/>
+          <p:cNvSpPr/>
+          <p:nvPr/>
+        </p:nvSpPr>
+        <p:spPr>
+          <a:xfrm>
+            <a:off x="640080" y="4023360"/>
+            <a:ext cx="3483864" cy="1828800"/>
+          </a:xfrm>
+          <a:prstGeom prst="roundRect">
+            <a:avLst>
+              <a:gd name="adj" fmla="val 5000"/>
+            </a:avLst>
+          </a:prstGeom>
+          <a:solidFill>
+            <a:srgbClr val="FFFFFF"/>
+          </a:solidFill>
+          <a:ln w="12700">
+            <a:solidFill>
+              <a:srgbClr val="DCE1E6"/>
+            </a:solidFill>
+            <a:prstDash val="solid"/>
+          </a:ln>
+          <a:effectLst>
+            <a:outerShdw sx="100000" sy="100000" kx="0" ky="0" algn="bl" rotWithShape="0" blurRad="88900" dist="25400" dir="5400000">
+              <a:srgbClr val="CBD2D8">
+                <a:alpha val="50000"/>
+              </a:srgbClr>
+            </a:outerShdw>
+          </a:effectLst>
+        </p:spPr>
+      </p:sp>
+      <p:sp>
+        <p:nvSpPr>
+          <p:cNvPr id="18" name="Shape 16"/>
+          <p:cNvSpPr/>
+          <p:nvPr/>
+        </p:nvSpPr>
+        <p:spPr>
+          <a:xfrm>
+            <a:off x="640080" y="4023360"/>
+            <a:ext cx="137160" cy="1828800"/>
+          </a:xfrm>
+          <a:prstGeom prst="roundRect">
+            <a:avLst>
+              <a:gd name="adj" fmla="val 13333"/>
+            </a:avLst>
+          </a:prstGeom>
+          <a:solidFill>
+            <a:srgbClr val="7A5C9E"/>
+          </a:solidFill>
+          <a:ln/>
+        </p:spPr>
+      </p:sp>
+      <p:sp>
+        <p:nvSpPr>
+          <p:cNvPr id="19" name="Text 17"/>
+          <p:cNvSpPr/>
+          <p:nvPr/>
+        </p:nvSpPr>
+        <p:spPr>
+          <a:xfrm>
+            <a:off x="1005840" y="4224528"/>
+            <a:ext cx="2889504" cy="457200"/>
+          </a:xfrm>
+          <a:prstGeom prst="rect">
+            <a:avLst/>
+          </a:prstGeom>
+          <a:noFill/>
+          <a:ln/>
+        </p:spPr>
+        <p:txBody>
+          <a:bodyPr wrap="square" rtlCol="0" anchor="ctr"/>
+          <a:lstStyle/>
+          <a:p>
+            <a:pPr indent="0" marL="0">
+              <a:lnSpc>
+                <a:spcPct val="95000"/>
+              </a:lnSpc>
+              <a:buNone/>
+            </a:pPr>
+            <a:r>
+              <a:rPr lang="en-US" sz="1600" b="1" dirty="0">
+                <a:solidFill>
+                  <a:srgbClr val="232F3E"/>
+                </a:solidFill>
+                <a:latin typeface="Calibri" pitchFamily="34" charset="0"/>
+                <a:ea typeface="Calibri" pitchFamily="34" charset="-122"/>
+                <a:cs typeface="Calibri" pitchFamily="34" charset="-120"/>
+              </a:rPr>
+              <a:t>Local Zones opt-in</a:t>
+            </a:r>
+            <a:endParaRPr lang="en-US" sz="1600" dirty="0"/>
+          </a:p>
+        </p:txBody>
+      </p:sp>
+      <p:sp>
+        <p:nvSpPr>
+          <p:cNvPr id="20" name="Text 18"/>
+          <p:cNvSpPr/>
+          <p:nvPr/>
+        </p:nvSpPr>
+        <p:spPr>
+          <a:xfrm>
+            <a:off x="1005840" y="4754880"/>
+            <a:ext cx="2843784" cy="914400"/>
+          </a:xfrm>
+          <a:prstGeom prst="rect">
+            <a:avLst/>
+          </a:prstGeom>
+          <a:noFill/>
+          <a:ln/>
+        </p:spPr>
+        <p:txBody>
+          <a:bodyPr wrap="square" rtlCol="0" anchor="ctr"/>
+          <a:lstStyle/>
+          <a:p>
+            <a:pPr indent="0" marL="0">
+              <a:lnSpc>
+                <a:spcPct val="103000"/>
+              </a:lnSpc>
+              <a:buNone/>
+            </a:pPr>
+            <a:r>
+              <a:rPr lang="en-US" sz="1300" dirty="0">
+                <a:solidFill>
+                  <a:srgbClr val="5B6570"/>
+                </a:solidFill>
+                <a:latin typeface="Calibri" pitchFamily="34" charset="0"/>
+                <a:ea typeface="Calibri" pitchFamily="34" charset="-122"/>
+                <a:cs typeface="Calibri" pitchFamily="34" charset="-120"/>
+              </a:rPr>
+              <a:t>Must be enabled per Region in Account Settings before they appear as a launch option.</a:t>
+            </a:r>
+            <a:endParaRPr lang="en-US" sz="1300" dirty="0"/>
+          </a:p>
+        </p:txBody>
+      </p:sp>
+      <p:sp>
+        <p:nvSpPr>
+          <p:cNvPr id="21" name="Shape 19"/>
+          <p:cNvSpPr/>
+          <p:nvPr/>
+        </p:nvSpPr>
+        <p:spPr>
+          <a:xfrm>
+            <a:off x="4352544" y="4023360"/>
+            <a:ext cx="3483864" cy="1828800"/>
+          </a:xfrm>
+          <a:prstGeom prst="roundRect">
+            <a:avLst>
+              <a:gd name="adj" fmla="val 5000"/>
+            </a:avLst>
+          </a:prstGeom>
+          <a:solidFill>
+            <a:srgbClr val="FFFFFF"/>
+          </a:solidFill>
+          <a:ln w="12700">
+            <a:solidFill>
+              <a:srgbClr val="DCE1E6"/>
+            </a:solidFill>
+            <a:prstDash val="solid"/>
+          </a:ln>
+          <a:effectLst>
+            <a:outerShdw sx="100000" sy="100000" kx="0" ky="0" algn="bl" rotWithShape="0" blurRad="88900" dist="25400" dir="5400000">
+              <a:srgbClr val="CBD2D8">
+                <a:alpha val="50000"/>
+              </a:srgbClr>
+            </a:outerShdw>
+          </a:effectLst>
+        </p:spPr>
+      </p:sp>
+      <p:sp>
+        <p:nvSpPr>
+          <p:cNvPr id="22" name="Shape 20"/>
+          <p:cNvSpPr/>
+          <p:nvPr/>
+        </p:nvSpPr>
+        <p:spPr>
+          <a:xfrm>
+            <a:off x="4352544" y="4023360"/>
+            <a:ext cx="137160" cy="1828800"/>
+          </a:xfrm>
+          <a:prstGeom prst="roundRect">
+            <a:avLst>
+              <a:gd name="adj" fmla="val 13333"/>
+            </a:avLst>
+          </a:prstGeom>
+          <a:solidFill>
+            <a:srgbClr val="4B6584"/>
+          </a:solidFill>
+          <a:ln/>
+        </p:spPr>
+      </p:sp>
+      <p:sp>
+        <p:nvSpPr>
+          <p:cNvPr id="23" name="Text 21"/>
+          <p:cNvSpPr/>
+          <p:nvPr/>
+        </p:nvSpPr>
+        <p:spPr>
+          <a:xfrm>
+            <a:off x="4718304" y="4224528"/>
+            <a:ext cx="2889504" cy="457200"/>
+          </a:xfrm>
+          <a:prstGeom prst="rect">
+            <a:avLst/>
+          </a:prstGeom>
+          <a:noFill/>
+          <a:ln/>
+        </p:spPr>
+        <p:txBody>
+          <a:bodyPr wrap="square" rtlCol="0" anchor="ctr"/>
+          <a:lstStyle/>
+          <a:p>
+            <a:pPr indent="0" marL="0">
+              <a:lnSpc>
+                <a:spcPct val="95000"/>
+              </a:lnSpc>
+              <a:buNone/>
+            </a:pPr>
+            <a:r>
+              <a:rPr lang="en-US" sz="1600" b="1" dirty="0">
+                <a:solidFill>
+                  <a:srgbClr val="232F3E"/>
+                </a:solidFill>
+                <a:latin typeface="Calibri" pitchFamily="34" charset="0"/>
+                <a:ea typeface="Calibri" pitchFamily="34" charset="-122"/>
+                <a:cs typeface="Calibri" pitchFamily="34" charset="-120"/>
+              </a:rPr>
+              <a:t>Global Infrastructure map</a:t>
+            </a:r>
+            <a:endParaRPr lang="en-US" sz="1600" dirty="0"/>
+          </a:p>
+        </p:txBody>
+      </p:sp>
+      <p:sp>
+        <p:nvSpPr>
+          <p:cNvPr id="24" name="Text 22"/>
+          <p:cNvSpPr/>
+          <p:nvPr/>
+        </p:nvSpPr>
+        <p:spPr>
+          <a:xfrm>
+            <a:off x="4718304" y="4754880"/>
+            <a:ext cx="2843784" cy="914400"/>
+          </a:xfrm>
+          <a:prstGeom prst="rect">
+            <a:avLst/>
+          </a:prstGeom>
+          <a:noFill/>
+          <a:ln/>
+        </p:spPr>
+        <p:txBody>
+          <a:bodyPr wrap="square" rtlCol="0" anchor="ctr"/>
+          <a:lstStyle/>
+          <a:p>
+            <a:pPr indent="0" marL="0">
+              <a:lnSpc>
+                <a:spcPct val="103000"/>
+              </a:lnSpc>
+              <a:buNone/>
+            </a:pPr>
+            <a:r>
+              <a:rPr lang="en-US" sz="1300" dirty="0">
+                <a:solidFill>
+                  <a:srgbClr val="5B6570"/>
+                </a:solidFill>
+                <a:latin typeface="Calibri" pitchFamily="34" charset="0"/>
+                <a:ea typeface="Calibri" pitchFamily="34" charset="-122"/>
+                <a:cs typeface="Calibri" pitchFamily="34" charset="-120"/>
+              </a:rPr>
+              <a:t>A public AWS page showing every Region and AZ count — no login required.</a:t>
+            </a:r>
+            <a:endParaRPr lang="en-US" sz="1300" dirty="0"/>
+          </a:p>
+        </p:txBody>
+      </p:sp>
+      <p:sp>
+        <p:nvSpPr>
+          <p:cNvPr id="25" name="Shape 23"/>
+          <p:cNvSpPr/>
+          <p:nvPr/>
+        </p:nvSpPr>
+        <p:spPr>
+          <a:xfrm>
+            <a:off x="8065008" y="4023360"/>
+            <a:ext cx="3483864" cy="1828800"/>
+          </a:xfrm>
+          <a:prstGeom prst="roundRect">
+            <a:avLst>
+              <a:gd name="adj" fmla="val 5000"/>
+            </a:avLst>
+          </a:prstGeom>
+          <a:solidFill>
+            <a:srgbClr val="FFFFFF"/>
+          </a:solidFill>
+          <a:ln w="12700">
+            <a:solidFill>
+              <a:srgbClr val="DCE1E6"/>
+            </a:solidFill>
+            <a:prstDash val="solid"/>
+          </a:ln>
+          <a:effectLst>
+            <a:outerShdw sx="100000" sy="100000" kx="0" ky="0" algn="bl" rotWithShape="0" blurRad="88900" dist="25400" dir="5400000">
+              <a:srgbClr val="CBD2D8">
+                <a:alpha val="50000"/>
+              </a:srgbClr>
+            </a:outerShdw>
+          </a:effectLst>
+        </p:spPr>
+      </p:sp>
+      <p:sp>
+        <p:nvSpPr>
+          <p:cNvPr id="26" name="Shape 24"/>
+          <p:cNvSpPr/>
+          <p:nvPr/>
+        </p:nvSpPr>
+        <p:spPr>
+          <a:xfrm>
+            <a:off x="8065008" y="4023360"/>
+            <a:ext cx="137160" cy="1828800"/>
+          </a:xfrm>
+          <a:prstGeom prst="roundRect">
+            <a:avLst>
+              <a:gd name="adj" fmla="val 13333"/>
+            </a:avLst>
+          </a:prstGeom>
+          <a:solidFill>
+            <a:srgbClr val="B7791F"/>
+          </a:solidFill>
+          <a:ln/>
+        </p:spPr>
+      </p:sp>
+      <p:sp>
+        <p:nvSpPr>
+          <p:cNvPr id="27" name="Text 25"/>
+          <p:cNvSpPr/>
+          <p:nvPr/>
+        </p:nvSpPr>
+        <p:spPr>
+          <a:xfrm>
+            <a:off x="8430768" y="4224528"/>
+            <a:ext cx="2889504" cy="457200"/>
+          </a:xfrm>
+          <a:prstGeom prst="rect">
+            <a:avLst/>
+          </a:prstGeom>
+          <a:noFill/>
+          <a:ln/>
+        </p:spPr>
+        <p:txBody>
+          <a:bodyPr wrap="square" rtlCol="0" anchor="ctr"/>
+          <a:lstStyle/>
+          <a:p>
+            <a:pPr indent="0" marL="0">
+              <a:lnSpc>
+                <a:spcPct val="95000"/>
+              </a:lnSpc>
+              <a:buNone/>
+            </a:pPr>
+            <a:r>
+              <a:rPr lang="en-US" sz="1600" b="1" dirty="0">
+                <a:solidFill>
+                  <a:srgbClr val="232F3E"/>
+                </a:solidFill>
+                <a:latin typeface="Calibri" pitchFamily="34" charset="0"/>
+                <a:ea typeface="Calibri" pitchFamily="34" charset="-122"/>
+                <a:cs typeface="Calibri" pitchFamily="34" charset="-120"/>
+              </a:rPr>
+              <a:t>Outposts console</a:t>
+            </a:r>
+            <a:endParaRPr lang="en-US" sz="1600" dirty="0"/>
+          </a:p>
+        </p:txBody>
+      </p:sp>
+      <p:sp>
+        <p:nvSpPr>
+          <p:cNvPr id="28" name="Text 26"/>
+          <p:cNvSpPr/>
+          <p:nvPr/>
+        </p:nvSpPr>
+        <p:spPr>
+          <a:xfrm>
+            <a:off x="8430768" y="4754880"/>
+            <a:ext cx="2843784" cy="914400"/>
+          </a:xfrm>
+          <a:prstGeom prst="rect">
+            <a:avLst/>
+          </a:prstGeom>
+          <a:noFill/>
+          <a:ln/>
+        </p:spPr>
+        <p:txBody>
+          <a:bodyPr wrap="square" rtlCol="0" anchor="ctr"/>
+          <a:lstStyle/>
+          <a:p>
+            <a:pPr indent="0" marL="0">
+              <a:lnSpc>
+                <a:spcPct val="103000"/>
+              </a:lnSpc>
+              <a:buNone/>
+            </a:pPr>
+            <a:r>
+              <a:rPr lang="en-US" sz="1300" dirty="0">
+                <a:solidFill>
+                  <a:srgbClr val="5B6570"/>
+                </a:solidFill>
+                <a:latin typeface="Calibri" pitchFamily="34" charset="0"/>
+                <a:ea typeface="Calibri" pitchFamily="34" charset="-122"/>
+                <a:cs typeface="Calibri" pitchFamily="34" charset="-120"/>
+              </a:rPr>
+              <a:t>Where you’d order and manage on-premises AWS hardware, if your organization uses it.</a:t>
+            </a:r>
+            <a:endParaRPr lang="en-US" sz="1300" dirty="0"/>
+          </a:p>
+        </p:txBody>
+      </p:sp>
+      <p:sp>
+        <p:nvSpPr>
+          <p:cNvPr id="29" name="Text 27"/>
+          <p:cNvSpPr/>
+          <p:nvPr/>
+        </p:nvSpPr>
+        <p:spPr>
+          <a:xfrm>
+            <a:off x="640080" y="5943600"/>
+            <a:ext cx="10908792" cy="365760"/>
+          </a:xfrm>
+          <a:prstGeom prst="rect">
+            <a:avLst/>
+          </a:prstGeom>
+          <a:noFill/>
+          <a:ln/>
+        </p:spPr>
+        <p:txBody>
+          <a:bodyPr wrap="square" rtlCol="0" anchor="ctr"/>
+          <a:lstStyle/>
+          <a:p>
+            <a:pPr algn="ctr" indent="0" marL="0">
+              <a:buNone/>
+            </a:pPr>
+            <a:r>
+              <a:rPr lang="en-US" sz="1350" i="1" dirty="0">
+                <a:solidFill>
+                  <a:srgbClr val="5B6570"/>
+                </a:solidFill>
+                <a:latin typeface="Calibri" pitchFamily="34" charset="0"/>
+                <a:ea typeface="Calibri" pitchFamily="34" charset="-122"/>
+                <a:cs typeface="Calibri" pitchFamily="34" charset="-120"/>
+              </a:rPr>
+              <a:t>Exam cue:  the exam won’t quiz you on console navigation directly, but knowing where a concept “lives” helps you recognize what a scenario is actually describing.</a:t>
+            </a:r>
+            <a:endParaRPr lang="en-US" sz="1350" dirty="0"/>
+          </a:p>
+        </p:txBody>
+      </p:sp>
+      <p:sp>
+        <p:nvSpPr>
+          <p:cNvPr id="30" name="Text 28"/>
+          <p:cNvSpPr/>
+          <p:nvPr/>
+        </p:nvSpPr>
+        <p:spPr>
+          <a:xfrm>
+            <a:off x="640080" y="6473952"/>
+            <a:ext cx="5943600" cy="274320"/>
+          </a:xfrm>
+          <a:prstGeom prst="rect">
+            <a:avLst/>
+          </a:prstGeom>
+          <a:noFill/>
+          <a:ln/>
+        </p:spPr>
+        <p:txBody>
+          <a:bodyPr wrap="square" rtlCol="0" anchor="ctr"/>
+          <a:lstStyle/>
+          <a:p>
+            <a:pPr indent="0" marL="0">
+              <a:buNone/>
+            </a:pPr>
+            <a:r>
+              <a:rPr lang="en-US" sz="900" dirty="0">
+                <a:solidFill>
+                  <a:srgbClr val="5B6570"/>
+                </a:solidFill>
+                <a:latin typeface="Calibri" pitchFamily="34" charset="0"/>
+                <a:ea typeface="Calibri" pitchFamily="34" charset="-122"/>
+                <a:cs typeface="Calibri" pitchFamily="34" charset="-120"/>
+              </a:rPr>
+              <a:t>AWS SAA-A  ·  Lecture 3  ·  AWS Global Infrastructure Overview</a:t>
+            </a:r>
+            <a:endParaRPr lang="en-US" sz="900" dirty="0"/>
+          </a:p>
+        </p:txBody>
+      </p:sp>
+      <p:sp>
+        <p:nvSpPr>
+          <p:cNvPr id="31" name="Text 29"/>
+          <p:cNvSpPr/>
+          <p:nvPr/>
+        </p:nvSpPr>
+        <p:spPr>
+          <a:xfrm>
+            <a:off x="11000232" y="6473952"/>
+            <a:ext cx="548640" cy="274320"/>
+          </a:xfrm>
+          <a:prstGeom prst="rect">
+            <a:avLst/>
+          </a:prstGeom>
+          <a:noFill/>
+          <a:ln/>
+        </p:spPr>
+        <p:txBody>
+          <a:bodyPr wrap="square" rtlCol="0" anchor="ctr"/>
+          <a:lstStyle/>
+          <a:p>
+            <a:pPr algn="r" indent="0" marL="0">
+              <a:buNone/>
+            </a:pPr>
+            <a:r>
+              <a:rPr lang="en-US" sz="900" dirty="0">
+                <a:solidFill>
+                  <a:srgbClr val="5B6570"/>
+                </a:solidFill>
+                <a:latin typeface="Calibri" pitchFamily="34" charset="0"/>
+                <a:ea typeface="Calibri" pitchFamily="34" charset="-122"/>
+                <a:cs typeface="Calibri" pitchFamily="34" charset="-120"/>
+              </a:rPr>
+              <a:t>14</a:t>
+            </a:r>
+            <a:endParaRPr lang="en-US" sz="900" dirty="0"/>
+          </a:p>
+        </p:txBody>
+      </p:sp>
+    </p:spTree>
+  </p:cSld>
+  <p:clrMapOvr>
+    <a:masterClrMapping/>
+  </p:clrMapOvr>
+</p:sld>
+</file>
+
+<file path=ppt/slides/slide38.xml><?xml version="1.0" encoding="utf-8"?>
+<p:sld xmlns:a="http://schemas.openxmlformats.org/drawingml/2006/main" xmlns:r="http://schemas.openxmlformats.org/officeDocument/2006/relationships" xmlns:p="http://schemas.openxmlformats.org/presentationml/2006/main">
   <p:cSld name="Slide 8">
     <p:bg>
       <p:bgPr>
@@ -8787,7 +13040,7 @@
                 <a:ea typeface="Calibri" pitchFamily="34" charset="-122"/>
                 <a:cs typeface="Calibri" pitchFamily="34" charset="-120"/>
               </a:rPr>
-              <a:t>10</a:t>
+              <a:t>15</a:t>
             </a:r>
             <a:endParaRPr lang="en-US" sz="900" dirty="0"/>
           </a:p>
@@ -8801,7 +13054,7 @@
 </p:sld>
 </file>
 
-<file path=ppt/slides/slide34.xml><?xml version="1.0" encoding="utf-8"?>
+<file path=ppt/slides/slide39.xml><?xml version="1.0" encoding="utf-8"?>
 <p:sld xmlns:a="http://schemas.openxmlformats.org/drawingml/2006/main" xmlns:r="http://schemas.openxmlformats.org/officeDocument/2006/relationships" xmlns:p="http://schemas.openxmlformats.org/presentationml/2006/main">
   <p:cSld name="Slide 17">
     <p:bg>
@@ -10131,7 +14384,7 @@
                 <a:ea typeface="Calibri" pitchFamily="34" charset="-122"/>
                 <a:cs typeface="Calibri" pitchFamily="34" charset="-120"/>
               </a:rPr>
-              <a:t>11</a:t>
+              <a:t>16</a:t>
             </a:r>
             <a:endParaRPr lang="en-US" sz="900" dirty="0"/>
           </a:p>
@@ -10145,7 +14398,7 @@
 </p:sld>
 </file>
 
-<file path=ppt/slides/slide35.xml><?xml version="1.0" encoding="utf-8"?>
+<file path=ppt/slides/slide40.xml><?xml version="1.0" encoding="utf-8"?>
 <p:sld xmlns:a="http://schemas.openxmlformats.org/drawingml/2006/main" xmlns:r="http://schemas.openxmlformats.org/officeDocument/2006/relationships" xmlns:p="http://schemas.openxmlformats.org/presentationml/2006/main">
   <p:cSld name="Slide 20">
     <p:bg>
@@ -11159,7 +15412,7 @@
                 <a:ea typeface="Calibri" pitchFamily="34" charset="-122"/>
                 <a:cs typeface="Calibri" pitchFamily="34" charset="-120"/>
               </a:rPr>
-              <a:t>12</a:t>
+              <a:t>17</a:t>
             </a:r>
             <a:endParaRPr lang="en-US" sz="900" dirty="0"/>
           </a:p>
@@ -11173,7 +15426,7 @@
 </p:sld>
 </file>
 
-<file path=ppt/slides/slide36.xml><?xml version="1.0" encoding="utf-8"?>
+<file path=ppt/slides/slide41.xml><?xml version="1.0" encoding="utf-8"?>
 <p:sld xmlns:a="http://schemas.openxmlformats.org/drawingml/2006/main" xmlns:r="http://schemas.openxmlformats.org/officeDocument/2006/relationships" xmlns:p="http://schemas.openxmlformats.org/presentationml/2006/main">
   <p:cSld name="Slide 21">
     <p:bg>
@@ -12031,7 +16284,7 @@
                 <a:ea typeface="Calibri" pitchFamily="34" charset="-122"/>
                 <a:cs typeface="Calibri" pitchFamily="34" charset="-120"/>
               </a:rPr>
-              <a:t>13</a:t>
+              <a:t>18</a:t>
             </a:r>
             <a:endParaRPr lang="en-US" sz="900" dirty="0"/>
           </a:p>
@@ -12045,7 +16298,7 @@
 </p:sld>
 </file>
 
-<file path=ppt/slides/slide37.xml><?xml version="1.0" encoding="utf-8"?>
+<file path=ppt/slides/slide42.xml><?xml version="1.0" encoding="utf-8"?>
 <p:sld xmlns:a="http://schemas.openxmlformats.org/drawingml/2006/main" xmlns:r="http://schemas.openxmlformats.org/officeDocument/2006/relationships" xmlns:p="http://schemas.openxmlformats.org/presentationml/2006/main">
   <p:cSld name="Slide 22">
     <p:bg>
@@ -12771,7 +17024,7 @@
                 <a:ea typeface="Calibri" pitchFamily="34" charset="-122"/>
                 <a:cs typeface="Calibri" pitchFamily="34" charset="-120"/>
               </a:rPr>
-              <a:t>14</a:t>
+              <a:t>19</a:t>
             </a:r>
             <a:endParaRPr lang="en-US" sz="900" dirty="0"/>
           </a:p>
@@ -12785,7 +17038,7 @@
 </p:sld>
 </file>
 
-<file path=ppt/slides/slide38.xml><?xml version="1.0" encoding="utf-8"?>
+<file path=ppt/slides/slide43.xml><?xml version="1.0" encoding="utf-8"?>
 <p:sld xmlns:a="http://schemas.openxmlformats.org/drawingml/2006/main" xmlns:r="http://schemas.openxmlformats.org/officeDocument/2006/relationships" xmlns:p="http://schemas.openxmlformats.org/presentationml/2006/main">
   <p:cSld name="Slide 23">
     <p:bg>

</xml_diff>